<commit_message>
fix: 사주교육 2·3회차 페이북(paybooc OTF) 폰트를 Pretendard Light로 교체
paybooc OTF 폰트가 Windows 폰트 캐시 손상 시 글리프 깨짐을 유발해,
2·3회차 슬라이드의 모든 paybooc OTF 참조(2회차 747건·3회차 642건)를
Pretendard Light로 치환. 크기·굵기·색상 등 다른 서식은 유지.
(1회차는 사용자가 동일 방식으로 선반영)
OOXML 검증 통과, 렌더 QA로 라벨·배지·스텝 카드 정상 표시 확인.

Co-Authored-By: Claude Opus 4.8 <noreply@anthropic.com>
</commit_message>
<xml_diff>
--- a/사주교육_2회차.pptx
+++ b/사주교육_2회차.pptx
@@ -698,9 +698,9 @@
                 <a:solidFill>
                   <a:srgbClr val="FFFFFF"/>
                 </a:solidFill>
-                <a:latin typeface="paybooc OTF" pitchFamily="34" charset="0"/>
-                <a:ea typeface="paybooc OTF" pitchFamily="34" charset="-122"/>
-                <a:cs typeface="paybooc OTF" pitchFamily="34" charset="-120"/>
+                <a:latin typeface="Pretendard Light" pitchFamily="34" charset="0"/>
+                <a:ea typeface="Pretendard Light" pitchFamily="34" charset="-122"/>
+                <a:cs typeface="Pretendard Light" pitchFamily="34" charset="-120"/>
               </a:rPr>
               <a:t>수수 사주교육</a:t>
             </a:r>
@@ -736,9 +736,9 @@
                 <a:solidFill>
                   <a:srgbClr val="A7E5D3"/>
                 </a:solidFill>
-                <a:latin typeface="paybooc OTF" pitchFamily="34" charset="0"/>
-                <a:ea typeface="paybooc OTF" pitchFamily="34" charset="-122"/>
-                <a:cs typeface="paybooc OTF" pitchFamily="34" charset="-120"/>
+                <a:latin typeface="Pretendard Light" pitchFamily="34" charset="0"/>
+                <a:ea typeface="Pretendard Light" pitchFamily="34" charset="-122"/>
+                <a:cs typeface="Pretendard Light" pitchFamily="34" charset="-120"/>
               </a:rPr>
               <a:t>SAJU TEACHER COURSE · SESSION 02</a:t>
             </a:r>
@@ -834,9 +834,9 @@
                 <a:solidFill>
                   <a:srgbClr val="A8A29E"/>
                 </a:solidFill>
-                <a:latin typeface="paybooc OTF" pitchFamily="34" charset="0"/>
-                <a:ea typeface="paybooc OTF" pitchFamily="34" charset="-122"/>
-                <a:cs typeface="paybooc OTF" pitchFamily="34" charset="-120"/>
+                <a:latin typeface="Pretendard Light" pitchFamily="34" charset="0"/>
+                <a:ea typeface="Pretendard Light" pitchFamily="34" charset="-122"/>
+                <a:cs typeface="Pretendard Light" pitchFamily="34" charset="-120"/>
               </a:rPr>
               <a:t>운(運)은 사주라는 자동차가 달리는 길이다</a:t>
             </a:r>
@@ -894,9 +894,9 @@
                 <a:solidFill>
                   <a:srgbClr val="FFFFFF"/>
                 </a:solidFill>
-                <a:latin typeface="paybooc OTF" pitchFamily="34" charset="0"/>
-                <a:ea typeface="paybooc OTF" pitchFamily="34" charset="-122"/>
-                <a:cs typeface="paybooc OTF" pitchFamily="34" charset="-120"/>
+                <a:latin typeface="Pretendard Light" pitchFamily="34" charset="0"/>
+                <a:ea typeface="Pretendard Light" pitchFamily="34" charset="-122"/>
+                <a:cs typeface="Pretendard Light" pitchFamily="34" charset="-120"/>
               </a:rPr>
               <a:t>2회차 · 대운·세운 읽는 법</a:t>
             </a:r>
@@ -1108,9 +1108,9 @@
                 <a:solidFill>
                   <a:srgbClr val="0C0A09"/>
                 </a:solidFill>
-                <a:latin typeface="paybooc OTF" pitchFamily="34" charset="0"/>
-                <a:ea typeface="paybooc OTF" pitchFamily="34" charset="-122"/>
-                <a:cs typeface="paybooc OTF" pitchFamily="34" charset="-120"/>
+                <a:latin typeface="Pretendard Light" pitchFamily="34" charset="0"/>
+                <a:ea typeface="Pretendard Light" pitchFamily="34" charset="-122"/>
+                <a:cs typeface="Pretendard Light" pitchFamily="34" charset="-120"/>
               </a:rPr>
               <a:t>수수 사주교육</a:t>
             </a:r>
@@ -1146,9 +1146,9 @@
                 <a:solidFill>
                   <a:srgbClr val="777169"/>
                 </a:solidFill>
-                <a:latin typeface="paybooc OTF" pitchFamily="34" charset="0"/>
-                <a:ea typeface="paybooc OTF" pitchFamily="34" charset="-122"/>
-                <a:cs typeface="paybooc OTF" pitchFamily="34" charset="-120"/>
+                <a:latin typeface="Pretendard Light" pitchFamily="34" charset="0"/>
+                <a:ea typeface="Pretendard Light" pitchFamily="34" charset="-122"/>
+                <a:cs typeface="Pretendard Light" pitchFamily="34" charset="-120"/>
               </a:rPr>
               <a:t>SECTION 02</a:t>
             </a:r>
@@ -1184,9 +1184,9 @@
                 <a:solidFill>
                   <a:srgbClr val="777169"/>
                 </a:solidFill>
-                <a:latin typeface="paybooc OTF" pitchFamily="34" charset="0"/>
-                <a:ea typeface="paybooc OTF" pitchFamily="34" charset="-122"/>
-                <a:cs typeface="paybooc OTF" pitchFamily="34" charset="-120"/>
+                <a:latin typeface="Pretendard Light" pitchFamily="34" charset="0"/>
+                <a:ea typeface="Pretendard Light" pitchFamily="34" charset="-122"/>
+                <a:cs typeface="Pretendard Light" pitchFamily="34" charset="-120"/>
               </a:rPr>
               <a:t>SECTION 02</a:t>
             </a:r>
@@ -1260,9 +1260,9 @@
                 <a:solidFill>
                   <a:srgbClr val="A8A29E"/>
                 </a:solidFill>
-                <a:latin typeface="paybooc OTF" pitchFamily="34" charset="0"/>
-                <a:ea typeface="paybooc OTF" pitchFamily="34" charset="-122"/>
-                <a:cs typeface="paybooc OTF" pitchFamily="34" charset="-120"/>
+                <a:latin typeface="Pretendard Light" pitchFamily="34" charset="0"/>
+                <a:ea typeface="Pretendard Light" pitchFamily="34" charset="-122"/>
+                <a:cs typeface="Pretendard Light" pitchFamily="34" charset="-120"/>
               </a:rPr>
               <a:t>THE TEN-YEAR CYCLE</a:t>
             </a:r>
@@ -1493,9 +1493,9 @@
                 <a:solidFill>
                   <a:srgbClr val="0C0A09"/>
                 </a:solidFill>
-                <a:latin typeface="paybooc OTF" pitchFamily="34" charset="0"/>
-                <a:ea typeface="paybooc OTF" pitchFamily="34" charset="-122"/>
-                <a:cs typeface="paybooc OTF" pitchFamily="34" charset="-120"/>
+                <a:latin typeface="Pretendard Light" pitchFamily="34" charset="0"/>
+                <a:ea typeface="Pretendard Light" pitchFamily="34" charset="-122"/>
+                <a:cs typeface="Pretendard Light" pitchFamily="34" charset="-120"/>
               </a:rPr>
               <a:t>수수 사주교육</a:t>
             </a:r>
@@ -1531,9 +1531,9 @@
                 <a:solidFill>
                   <a:srgbClr val="777169"/>
                 </a:solidFill>
-                <a:latin typeface="paybooc OTF" pitchFamily="34" charset="0"/>
-                <a:ea typeface="paybooc OTF" pitchFamily="34" charset="-122"/>
-                <a:cs typeface="paybooc OTF" pitchFamily="34" charset="-120"/>
+                <a:latin typeface="Pretendard Light" pitchFamily="34" charset="0"/>
+                <a:ea typeface="Pretendard Light" pitchFamily="34" charset="-122"/>
+                <a:cs typeface="Pretendard Light" pitchFamily="34" charset="-120"/>
               </a:rPr>
               <a:t>02</a:t>
             </a:r>
@@ -1569,9 +1569,9 @@
                 <a:solidFill>
                   <a:srgbClr val="777169"/>
                 </a:solidFill>
-                <a:latin typeface="paybooc OTF" pitchFamily="34" charset="0"/>
-                <a:ea typeface="paybooc OTF" pitchFamily="34" charset="-122"/>
-                <a:cs typeface="paybooc OTF" pitchFamily="34" charset="-120"/>
+                <a:latin typeface="Pretendard Light" pitchFamily="34" charset="0"/>
+                <a:ea typeface="Pretendard Light" pitchFamily="34" charset="-122"/>
+                <a:cs typeface="Pretendard Light" pitchFamily="34" charset="-120"/>
               </a:rPr>
               <a:t>02 · 대운(大運)</a:t>
             </a:r>
@@ -1645,9 +1645,9 @@
                 <a:solidFill>
                   <a:srgbClr val="777169"/>
                 </a:solidFill>
-                <a:latin typeface="paybooc OTF" pitchFamily="34" charset="0"/>
-                <a:ea typeface="paybooc OTF" pitchFamily="34" charset="-122"/>
-                <a:cs typeface="paybooc OTF" pitchFamily="34" charset="-120"/>
+                <a:latin typeface="Pretendard Light" pitchFamily="34" charset="0"/>
+                <a:ea typeface="Pretendard Light" pitchFamily="34" charset="-122"/>
+                <a:cs typeface="Pretendard Light" pitchFamily="34" charset="-120"/>
               </a:rPr>
               <a:t>10년마다 바뀌는 삶의 큰 배경</a:t>
             </a:r>
@@ -1717,9 +1717,9 @@
                 <a:solidFill>
                   <a:srgbClr val="777169"/>
                 </a:solidFill>
-                <a:latin typeface="paybooc OTF" pitchFamily="34" charset="0"/>
-                <a:ea typeface="paybooc OTF" pitchFamily="34" charset="-122"/>
-                <a:cs typeface="paybooc OTF" pitchFamily="34" charset="-120"/>
+                <a:latin typeface="Pretendard Light" pitchFamily="34" charset="0"/>
+                <a:ea typeface="Pretendard Light" pitchFamily="34" charset="-122"/>
+                <a:cs typeface="Pretendard Light" pitchFamily="34" charset="-120"/>
               </a:rPr>
               <a:t>주기</a:t>
             </a:r>
@@ -1755,9 +1755,9 @@
                 <a:solidFill>
                   <a:srgbClr val="0C0A09"/>
                 </a:solidFill>
-                <a:latin typeface="paybooc OTF" pitchFamily="34" charset="0"/>
-                <a:ea typeface="paybooc OTF" pitchFamily="34" charset="-122"/>
-                <a:cs typeface="paybooc OTF" pitchFamily="34" charset="-120"/>
+                <a:latin typeface="Pretendard Light" pitchFamily="34" charset="0"/>
+                <a:ea typeface="Pretendard Light" pitchFamily="34" charset="-122"/>
+                <a:cs typeface="Pretendard Light" pitchFamily="34" charset="-120"/>
               </a:rPr>
               <a:t>10년 단위</a:t>
             </a:r>
@@ -1868,9 +1868,9 @@
                 <a:solidFill>
                   <a:srgbClr val="777169"/>
                 </a:solidFill>
-                <a:latin typeface="paybooc OTF" pitchFamily="34" charset="0"/>
-                <a:ea typeface="paybooc OTF" pitchFamily="34" charset="-122"/>
-                <a:cs typeface="paybooc OTF" pitchFamily="34" charset="-120"/>
+                <a:latin typeface="Pretendard Light" pitchFamily="34" charset="0"/>
+                <a:ea typeface="Pretendard Light" pitchFamily="34" charset="-122"/>
+                <a:cs typeface="Pretendard Light" pitchFamily="34" charset="-120"/>
               </a:rPr>
               <a:t>성격</a:t>
             </a:r>
@@ -1906,9 +1906,9 @@
                 <a:solidFill>
                   <a:srgbClr val="0C0A09"/>
                 </a:solidFill>
-                <a:latin typeface="paybooc OTF" pitchFamily="34" charset="0"/>
-                <a:ea typeface="paybooc OTF" pitchFamily="34" charset="-122"/>
-                <a:cs typeface="paybooc OTF" pitchFamily="34" charset="-120"/>
+                <a:latin typeface="Pretendard Light" pitchFamily="34" charset="0"/>
+                <a:ea typeface="Pretendard Light" pitchFamily="34" charset="-122"/>
+                <a:cs typeface="Pretendard Light" pitchFamily="34" charset="-120"/>
               </a:rPr>
               <a:t>큰 줄기</a:t>
             </a:r>
@@ -2019,9 +2019,9 @@
                 <a:solidFill>
                   <a:srgbClr val="777169"/>
                 </a:solidFill>
-                <a:latin typeface="paybooc OTF" pitchFamily="34" charset="0"/>
-                <a:ea typeface="paybooc OTF" pitchFamily="34" charset="-122"/>
-                <a:cs typeface="paybooc OTF" pitchFamily="34" charset="-120"/>
+                <a:latin typeface="Pretendard Light" pitchFamily="34" charset="0"/>
+                <a:ea typeface="Pretendard Light" pitchFamily="34" charset="-122"/>
+                <a:cs typeface="Pretendard Light" pitchFamily="34" charset="-120"/>
               </a:rPr>
               <a:t>범위</a:t>
             </a:r>
@@ -2057,9 +2057,9 @@
                 <a:solidFill>
                   <a:srgbClr val="0C0A09"/>
                 </a:solidFill>
-                <a:latin typeface="paybooc OTF" pitchFamily="34" charset="0"/>
-                <a:ea typeface="paybooc OTF" pitchFamily="34" charset="-122"/>
-                <a:cs typeface="paybooc OTF" pitchFamily="34" charset="-120"/>
+                <a:latin typeface="Pretendard Light" pitchFamily="34" charset="0"/>
+                <a:ea typeface="Pretendard Light" pitchFamily="34" charset="-122"/>
+                <a:cs typeface="Pretendard Light" pitchFamily="34" charset="-120"/>
               </a:rPr>
               <a:t>배경 전체</a:t>
             </a:r>
@@ -2170,9 +2170,9 @@
                 <a:solidFill>
                   <a:srgbClr val="DC2626"/>
                 </a:solidFill>
-                <a:latin typeface="paybooc OTF" pitchFamily="34" charset="0"/>
-                <a:ea typeface="paybooc OTF" pitchFamily="34" charset="-122"/>
-                <a:cs typeface="paybooc OTF" pitchFamily="34" charset="-120"/>
+                <a:latin typeface="Pretendard Light" pitchFamily="34" charset="0"/>
+                <a:ea typeface="Pretendard Light" pitchFamily="34" charset="-122"/>
+                <a:cs typeface="Pretendard Light" pitchFamily="34" charset="-120"/>
               </a:rPr>
               <a:t>오해 주의</a:t>
             </a:r>
@@ -2403,9 +2403,9 @@
                 <a:solidFill>
                   <a:srgbClr val="0C0A09"/>
                 </a:solidFill>
-                <a:latin typeface="paybooc OTF" pitchFamily="34" charset="0"/>
-                <a:ea typeface="paybooc OTF" pitchFamily="34" charset="-122"/>
-                <a:cs typeface="paybooc OTF" pitchFamily="34" charset="-120"/>
+                <a:latin typeface="Pretendard Light" pitchFamily="34" charset="0"/>
+                <a:ea typeface="Pretendard Light" pitchFamily="34" charset="-122"/>
+                <a:cs typeface="Pretendard Light" pitchFamily="34" charset="-120"/>
               </a:rPr>
               <a:t>수수 사주교육</a:t>
             </a:r>
@@ -2441,9 +2441,9 @@
                 <a:solidFill>
                   <a:srgbClr val="777169"/>
                 </a:solidFill>
-                <a:latin typeface="paybooc OTF" pitchFamily="34" charset="0"/>
-                <a:ea typeface="paybooc OTF" pitchFamily="34" charset="-122"/>
-                <a:cs typeface="paybooc OTF" pitchFamily="34" charset="-120"/>
+                <a:latin typeface="Pretendard Light" pitchFamily="34" charset="0"/>
+                <a:ea typeface="Pretendard Light" pitchFamily="34" charset="-122"/>
+                <a:cs typeface="Pretendard Light" pitchFamily="34" charset="-120"/>
               </a:rPr>
               <a:t>02</a:t>
             </a:r>
@@ -2479,9 +2479,9 @@
                 <a:solidFill>
                   <a:srgbClr val="777169"/>
                 </a:solidFill>
-                <a:latin typeface="paybooc OTF" pitchFamily="34" charset="0"/>
-                <a:ea typeface="paybooc OTF" pitchFamily="34" charset="-122"/>
-                <a:cs typeface="paybooc OTF" pitchFamily="34" charset="-120"/>
+                <a:latin typeface="Pretendard Light" pitchFamily="34" charset="0"/>
+                <a:ea typeface="Pretendard Light" pitchFamily="34" charset="-122"/>
+                <a:cs typeface="Pretendard Light" pitchFamily="34" charset="-120"/>
               </a:rPr>
               <a:t>02 · 대운(大運)</a:t>
             </a:r>
@@ -2555,9 +2555,9 @@
                 <a:solidFill>
                   <a:srgbClr val="777169"/>
                 </a:solidFill>
-                <a:latin typeface="paybooc OTF" pitchFamily="34" charset="0"/>
-                <a:ea typeface="paybooc OTF" pitchFamily="34" charset="-122"/>
-                <a:cs typeface="paybooc OTF" pitchFamily="34" charset="-120"/>
+                <a:latin typeface="Pretendard Light" pitchFamily="34" charset="0"/>
+                <a:ea typeface="Pretendard Light" pitchFamily="34" charset="-122"/>
+                <a:cs typeface="Pretendard Light" pitchFamily="34" charset="-120"/>
               </a:rPr>
               <a:t>첫 대운이 몇 살에 시작되나</a:t>
             </a:r>
@@ -2627,9 +2627,9 @@
                 <a:solidFill>
                   <a:srgbClr val="777169"/>
                 </a:solidFill>
-                <a:latin typeface="paybooc OTF" pitchFamily="34" charset="0"/>
-                <a:ea typeface="paybooc OTF" pitchFamily="34" charset="-122"/>
-                <a:cs typeface="paybooc OTF" pitchFamily="34" charset="-120"/>
+                <a:latin typeface="Pretendard Light" pitchFamily="34" charset="0"/>
+                <a:ea typeface="Pretendard Light" pitchFamily="34" charset="-122"/>
+                <a:cs typeface="Pretendard Light" pitchFamily="34" charset="-120"/>
               </a:rPr>
               <a:t>대운수란</a:t>
             </a:r>
@@ -2800,9 +2800,9 @@
                 <a:solidFill>
                   <a:srgbClr val="0C0A09"/>
                 </a:solidFill>
-                <a:latin typeface="paybooc OTF" pitchFamily="34" charset="0"/>
-                <a:ea typeface="paybooc OTF" pitchFamily="34" charset="-122"/>
-                <a:cs typeface="paybooc OTF" pitchFamily="34" charset="-120"/>
+                <a:latin typeface="Pretendard Light" pitchFamily="34" charset="0"/>
+                <a:ea typeface="Pretendard Light" pitchFamily="34" charset="-122"/>
+                <a:cs typeface="Pretendard Light" pitchFamily="34" charset="-120"/>
               </a:rPr>
               <a:t>태어난 날 → 가까운 절기까지 날짜를 센다</a:t>
             </a:r>
@@ -2973,9 +2973,9 @@
                 <a:solidFill>
                   <a:srgbClr val="0C0A09"/>
                 </a:solidFill>
-                <a:latin typeface="paybooc OTF" pitchFamily="34" charset="0"/>
-                <a:ea typeface="paybooc OTF" pitchFamily="34" charset="-122"/>
-                <a:cs typeface="paybooc OTF" pitchFamily="34" charset="-120"/>
+                <a:latin typeface="Pretendard Light" pitchFamily="34" charset="0"/>
+                <a:ea typeface="Pretendard Light" pitchFamily="34" charset="-122"/>
+                <a:cs typeface="Pretendard Light" pitchFamily="34" charset="-120"/>
               </a:rPr>
               <a:t>그 일수를 3으로 나눈다</a:t>
             </a:r>
@@ -3146,9 +3146,9 @@
                 <a:solidFill>
                   <a:srgbClr val="0C0A09"/>
                 </a:solidFill>
-                <a:latin typeface="paybooc OTF" pitchFamily="34" charset="0"/>
-                <a:ea typeface="paybooc OTF" pitchFamily="34" charset="-122"/>
-                <a:cs typeface="paybooc OTF" pitchFamily="34" charset="-120"/>
+                <a:latin typeface="Pretendard Light" pitchFamily="34" charset="0"/>
+                <a:ea typeface="Pretendard Light" pitchFamily="34" charset="-122"/>
+                <a:cs typeface="Pretendard Light" pitchFamily="34" charset="-120"/>
               </a:rPr>
               <a:t>그 나이부터 10년 주기로 진행</a:t>
             </a:r>
@@ -3417,9 +3417,9 @@
                 <a:solidFill>
                   <a:srgbClr val="0C0A09"/>
                 </a:solidFill>
-                <a:latin typeface="paybooc OTF" pitchFamily="34" charset="0"/>
-                <a:ea typeface="paybooc OTF" pitchFamily="34" charset="-122"/>
-                <a:cs typeface="paybooc OTF" pitchFamily="34" charset="-120"/>
+                <a:latin typeface="Pretendard Light" pitchFamily="34" charset="0"/>
+                <a:ea typeface="Pretendard Light" pitchFamily="34" charset="-122"/>
+                <a:cs typeface="Pretendard Light" pitchFamily="34" charset="-120"/>
               </a:rPr>
               <a:t>수수 사주교육</a:t>
             </a:r>
@@ -3455,9 +3455,9 @@
                 <a:solidFill>
                   <a:srgbClr val="777169"/>
                 </a:solidFill>
-                <a:latin typeface="paybooc OTF" pitchFamily="34" charset="0"/>
-                <a:ea typeface="paybooc OTF" pitchFamily="34" charset="-122"/>
-                <a:cs typeface="paybooc OTF" pitchFamily="34" charset="-120"/>
+                <a:latin typeface="Pretendard Light" pitchFamily="34" charset="0"/>
+                <a:ea typeface="Pretendard Light" pitchFamily="34" charset="-122"/>
+                <a:cs typeface="Pretendard Light" pitchFamily="34" charset="-120"/>
               </a:rPr>
               <a:t>02</a:t>
             </a:r>
@@ -3493,9 +3493,9 @@
                 <a:solidFill>
                   <a:srgbClr val="777169"/>
                 </a:solidFill>
-                <a:latin typeface="paybooc OTF" pitchFamily="34" charset="0"/>
-                <a:ea typeface="paybooc OTF" pitchFamily="34" charset="-122"/>
-                <a:cs typeface="paybooc OTF" pitchFamily="34" charset="-120"/>
+                <a:latin typeface="Pretendard Light" pitchFamily="34" charset="0"/>
+                <a:ea typeface="Pretendard Light" pitchFamily="34" charset="-122"/>
+                <a:cs typeface="Pretendard Light" pitchFamily="34" charset="-120"/>
               </a:rPr>
               <a:t>02 · 대운(大運)</a:t>
             </a:r>
@@ -3569,9 +3569,9 @@
                 <a:solidFill>
                   <a:srgbClr val="777169"/>
                 </a:solidFill>
-                <a:latin typeface="paybooc OTF" pitchFamily="34" charset="0"/>
-                <a:ea typeface="paybooc OTF" pitchFamily="34" charset="-122"/>
-                <a:cs typeface="paybooc OTF" pitchFamily="34" charset="-120"/>
+                <a:latin typeface="Pretendard Light" pitchFamily="34" charset="0"/>
+                <a:ea typeface="Pretendard Light" pitchFamily="34" charset="-122"/>
+                <a:cs typeface="Pretendard Light" pitchFamily="34" charset="-120"/>
               </a:rPr>
               <a:t>대운이 나아가는 방향</a:t>
             </a:r>
@@ -3663,9 +3663,9 @@
                 <a:solidFill>
                   <a:srgbClr val="777169"/>
                 </a:solidFill>
-                <a:latin typeface="paybooc OTF" pitchFamily="34" charset="0"/>
-                <a:ea typeface="paybooc OTF" pitchFamily="34" charset="-122"/>
-                <a:cs typeface="paybooc OTF" pitchFamily="34" charset="-120"/>
+                <a:latin typeface="Pretendard Light" pitchFamily="34" charset="0"/>
+                <a:ea typeface="Pretendard Light" pitchFamily="34" charset="-122"/>
+                <a:cs typeface="Pretendard Light" pitchFamily="34" charset="-120"/>
               </a:rPr>
               <a:t>順行 · 순행</a:t>
             </a:r>
@@ -3701,9 +3701,9 @@
                 <a:solidFill>
                   <a:srgbClr val="0C0A09"/>
                 </a:solidFill>
-                <a:latin typeface="paybooc OTF" pitchFamily="34" charset="0"/>
-                <a:ea typeface="paybooc OTF" pitchFamily="34" charset="-122"/>
-                <a:cs typeface="paybooc OTF" pitchFamily="34" charset="-120"/>
+                <a:latin typeface="Pretendard Light" pitchFamily="34" charset="0"/>
+                <a:ea typeface="Pretendard Light" pitchFamily="34" charset="-122"/>
+                <a:cs typeface="Pretendard Light" pitchFamily="34" charset="-120"/>
               </a:rPr>
               <a:t>간지가 앞으로</a:t>
             </a:r>
@@ -3897,9 +3897,9 @@
                 <a:solidFill>
                   <a:srgbClr val="777169"/>
                 </a:solidFill>
-                <a:latin typeface="paybooc OTF" pitchFamily="34" charset="0"/>
-                <a:ea typeface="paybooc OTF" pitchFamily="34" charset="-122"/>
-                <a:cs typeface="paybooc OTF" pitchFamily="34" charset="-120"/>
+                <a:latin typeface="Pretendard Light" pitchFamily="34" charset="0"/>
+                <a:ea typeface="Pretendard Light" pitchFamily="34" charset="-122"/>
+                <a:cs typeface="Pretendard Light" pitchFamily="34" charset="-120"/>
               </a:rPr>
               <a:t>逆行 · 역행</a:t>
             </a:r>
@@ -3935,9 +3935,9 @@
                 <a:solidFill>
                   <a:srgbClr val="0C0A09"/>
                 </a:solidFill>
-                <a:latin typeface="paybooc OTF" pitchFamily="34" charset="0"/>
-                <a:ea typeface="paybooc OTF" pitchFamily="34" charset="-122"/>
-                <a:cs typeface="paybooc OTF" pitchFamily="34" charset="-120"/>
+                <a:latin typeface="Pretendard Light" pitchFamily="34" charset="0"/>
+                <a:ea typeface="Pretendard Light" pitchFamily="34" charset="-122"/>
+                <a:cs typeface="Pretendard Light" pitchFamily="34" charset="-120"/>
               </a:rPr>
               <a:t>간지가 거꾸로</a:t>
             </a:r>
@@ -4109,9 +4109,9 @@
                 <a:solidFill>
                   <a:srgbClr val="777169"/>
                 </a:solidFill>
-                <a:latin typeface="paybooc OTF" pitchFamily="34" charset="0"/>
-                <a:ea typeface="paybooc OTF" pitchFamily="34" charset="-122"/>
-                <a:cs typeface="paybooc OTF" pitchFamily="34" charset="-120"/>
+                <a:latin typeface="Pretendard Light" pitchFamily="34" charset="0"/>
+                <a:ea typeface="Pretendard Light" pitchFamily="34" charset="-122"/>
+                <a:cs typeface="Pretendard Light" pitchFamily="34" charset="-120"/>
               </a:rPr>
               <a:t>판별법</a:t>
             </a:r>
@@ -4342,9 +4342,9 @@
                 <a:solidFill>
                   <a:srgbClr val="0C0A09"/>
                 </a:solidFill>
-                <a:latin typeface="paybooc OTF" pitchFamily="34" charset="0"/>
-                <a:ea typeface="paybooc OTF" pitchFamily="34" charset="-122"/>
-                <a:cs typeface="paybooc OTF" pitchFamily="34" charset="-120"/>
+                <a:latin typeface="Pretendard Light" pitchFamily="34" charset="0"/>
+                <a:ea typeface="Pretendard Light" pitchFamily="34" charset="-122"/>
+                <a:cs typeface="Pretendard Light" pitchFamily="34" charset="-120"/>
               </a:rPr>
               <a:t>수수 사주교육</a:t>
             </a:r>
@@ -4380,9 +4380,9 @@
                 <a:solidFill>
                   <a:srgbClr val="777169"/>
                 </a:solidFill>
-                <a:latin typeface="paybooc OTF" pitchFamily="34" charset="0"/>
-                <a:ea typeface="paybooc OTF" pitchFamily="34" charset="-122"/>
-                <a:cs typeface="paybooc OTF" pitchFamily="34" charset="-120"/>
+                <a:latin typeface="Pretendard Light" pitchFamily="34" charset="0"/>
+                <a:ea typeface="Pretendard Light" pitchFamily="34" charset="-122"/>
+                <a:cs typeface="Pretendard Light" pitchFamily="34" charset="-120"/>
               </a:rPr>
               <a:t>02</a:t>
             </a:r>
@@ -4418,9 +4418,9 @@
                 <a:solidFill>
                   <a:srgbClr val="777169"/>
                 </a:solidFill>
-                <a:latin typeface="paybooc OTF" pitchFamily="34" charset="0"/>
-                <a:ea typeface="paybooc OTF" pitchFamily="34" charset="-122"/>
-                <a:cs typeface="paybooc OTF" pitchFamily="34" charset="-120"/>
+                <a:latin typeface="Pretendard Light" pitchFamily="34" charset="0"/>
+                <a:ea typeface="Pretendard Light" pitchFamily="34" charset="-122"/>
+                <a:cs typeface="Pretendard Light" pitchFamily="34" charset="-120"/>
               </a:rPr>
               <a:t>02 · 대운(大運)</a:t>
             </a:r>
@@ -4494,9 +4494,9 @@
                 <a:solidFill>
                   <a:srgbClr val="777169"/>
                 </a:solidFill>
-                <a:latin typeface="paybooc OTF" pitchFamily="34" charset="0"/>
-                <a:ea typeface="paybooc OTF" pitchFamily="34" charset="-122"/>
-                <a:cs typeface="paybooc OTF" pitchFamily="34" charset="-120"/>
+                <a:latin typeface="Pretendard Light" pitchFamily="34" charset="0"/>
+                <a:ea typeface="Pretendard Light" pitchFamily="34" charset="-122"/>
+                <a:cs typeface="Pretendard Light" pitchFamily="34" charset="-120"/>
               </a:rPr>
               <a:t>한 기둥(2글자)을 앞·뒤 5년으로</a:t>
             </a:r>
@@ -4566,9 +4566,9 @@
                 <a:solidFill>
                   <a:srgbClr val="777169"/>
                 </a:solidFill>
-                <a:latin typeface="paybooc OTF" pitchFamily="34" charset="0"/>
-                <a:ea typeface="paybooc OTF" pitchFamily="34" charset="-122"/>
-                <a:cs typeface="paybooc OTF" pitchFamily="34" charset="-120"/>
+                <a:latin typeface="Pretendard Light" pitchFamily="34" charset="0"/>
+                <a:ea typeface="Pretendard Light" pitchFamily="34" charset="-122"/>
+                <a:cs typeface="Pretendard Light" pitchFamily="34" charset="-120"/>
               </a:rPr>
               <a:t>간지</a:t>
             </a:r>
@@ -4604,9 +4604,9 @@
                 <a:solidFill>
                   <a:srgbClr val="0C0A09"/>
                 </a:solidFill>
-                <a:latin typeface="paybooc OTF" pitchFamily="34" charset="0"/>
-                <a:ea typeface="paybooc OTF" pitchFamily="34" charset="-122"/>
-                <a:cs typeface="paybooc OTF" pitchFamily="34" charset="-120"/>
+                <a:latin typeface="Pretendard Light" pitchFamily="34" charset="0"/>
+                <a:ea typeface="Pretendard Light" pitchFamily="34" charset="-122"/>
+                <a:cs typeface="Pretendard Light" pitchFamily="34" charset="-120"/>
               </a:rPr>
               <a:t>두 글자가 한 칸</a:t>
             </a:r>
@@ -4717,9 +4717,9 @@
                 <a:solidFill>
                   <a:srgbClr val="777169"/>
                 </a:solidFill>
-                <a:latin typeface="paybooc OTF" pitchFamily="34" charset="0"/>
-                <a:ea typeface="paybooc OTF" pitchFamily="34" charset="-122"/>
-                <a:cs typeface="paybooc OTF" pitchFamily="34" charset="-120"/>
+                <a:latin typeface="Pretendard Light" pitchFamily="34" charset="0"/>
+                <a:ea typeface="Pretendard Light" pitchFamily="34" charset="-122"/>
+                <a:cs typeface="Pretendard Light" pitchFamily="34" charset="-120"/>
               </a:rPr>
               <a:t>앞 5년</a:t>
             </a:r>
@@ -4755,9 +4755,9 @@
                 <a:solidFill>
                   <a:srgbClr val="0C0A09"/>
                 </a:solidFill>
-                <a:latin typeface="paybooc OTF" pitchFamily="34" charset="0"/>
-                <a:ea typeface="paybooc OTF" pitchFamily="34" charset="-122"/>
-                <a:cs typeface="paybooc OTF" pitchFamily="34" charset="-120"/>
+                <a:latin typeface="Pretendard Light" pitchFamily="34" charset="0"/>
+                <a:ea typeface="Pretendard Light" pitchFamily="34" charset="-122"/>
+                <a:cs typeface="Pretendard Light" pitchFamily="34" charset="-120"/>
               </a:rPr>
               <a:t>천간이 주도</a:t>
             </a:r>
@@ -4868,9 +4868,9 @@
                 <a:solidFill>
                   <a:srgbClr val="777169"/>
                 </a:solidFill>
-                <a:latin typeface="paybooc OTF" pitchFamily="34" charset="0"/>
-                <a:ea typeface="paybooc OTF" pitchFamily="34" charset="-122"/>
-                <a:cs typeface="paybooc OTF" pitchFamily="34" charset="-120"/>
+                <a:latin typeface="Pretendard Light" pitchFamily="34" charset="0"/>
+                <a:ea typeface="Pretendard Light" pitchFamily="34" charset="-122"/>
+                <a:cs typeface="Pretendard Light" pitchFamily="34" charset="-120"/>
               </a:rPr>
               <a:t>뒤 5년</a:t>
             </a:r>
@@ -4906,9 +4906,9 @@
                 <a:solidFill>
                   <a:srgbClr val="0C0A09"/>
                 </a:solidFill>
-                <a:latin typeface="paybooc OTF" pitchFamily="34" charset="0"/>
-                <a:ea typeface="paybooc OTF" pitchFamily="34" charset="-122"/>
-                <a:cs typeface="paybooc OTF" pitchFamily="34" charset="-120"/>
+                <a:latin typeface="Pretendard Light" pitchFamily="34" charset="0"/>
+                <a:ea typeface="Pretendard Light" pitchFamily="34" charset="-122"/>
+                <a:cs typeface="Pretendard Light" pitchFamily="34" charset="-120"/>
               </a:rPr>
               <a:t>지지가 주도</a:t>
             </a:r>
@@ -5019,9 +5019,9 @@
                 <a:solidFill>
                   <a:srgbClr val="777169"/>
                 </a:solidFill>
-                <a:latin typeface="paybooc OTF" pitchFamily="34" charset="0"/>
-                <a:ea typeface="paybooc OTF" pitchFamily="34" charset="-122"/>
-                <a:cs typeface="paybooc OTF" pitchFamily="34" charset="-120"/>
+                <a:latin typeface="Pretendard Light" pitchFamily="34" charset="0"/>
+                <a:ea typeface="Pretendard Light" pitchFamily="34" charset="-122"/>
+                <a:cs typeface="Pretendard Light" pitchFamily="34" charset="-120"/>
               </a:rPr>
               <a:t>실전 팁</a:t>
             </a:r>
@@ -5274,9 +5274,9 @@
                 <a:solidFill>
                   <a:srgbClr val="0C0A09"/>
                 </a:solidFill>
-                <a:latin typeface="paybooc OTF" pitchFamily="34" charset="0"/>
-                <a:ea typeface="paybooc OTF" pitchFamily="34" charset="-122"/>
-                <a:cs typeface="paybooc OTF" pitchFamily="34" charset="-120"/>
+                <a:latin typeface="Pretendard Light" pitchFamily="34" charset="0"/>
+                <a:ea typeface="Pretendard Light" pitchFamily="34" charset="-122"/>
+                <a:cs typeface="Pretendard Light" pitchFamily="34" charset="-120"/>
               </a:rPr>
               <a:t>수수 사주교육</a:t>
             </a:r>
@@ -5312,9 +5312,9 @@
                 <a:solidFill>
                   <a:srgbClr val="777169"/>
                 </a:solidFill>
-                <a:latin typeface="paybooc OTF" pitchFamily="34" charset="0"/>
-                <a:ea typeface="paybooc OTF" pitchFamily="34" charset="-122"/>
-                <a:cs typeface="paybooc OTF" pitchFamily="34" charset="-120"/>
+                <a:latin typeface="Pretendard Light" pitchFamily="34" charset="0"/>
+                <a:ea typeface="Pretendard Light" pitchFamily="34" charset="-122"/>
+                <a:cs typeface="Pretendard Light" pitchFamily="34" charset="-120"/>
               </a:rPr>
               <a:t>SECTION 03</a:t>
             </a:r>
@@ -5350,9 +5350,9 @@
                 <a:solidFill>
                   <a:srgbClr val="777169"/>
                 </a:solidFill>
-                <a:latin typeface="paybooc OTF" pitchFamily="34" charset="0"/>
-                <a:ea typeface="paybooc OTF" pitchFamily="34" charset="-122"/>
-                <a:cs typeface="paybooc OTF" pitchFamily="34" charset="-120"/>
+                <a:latin typeface="Pretendard Light" pitchFamily="34" charset="0"/>
+                <a:ea typeface="Pretendard Light" pitchFamily="34" charset="-122"/>
+                <a:cs typeface="Pretendard Light" pitchFamily="34" charset="-120"/>
               </a:rPr>
               <a:t>SECTION 03</a:t>
             </a:r>
@@ -5426,9 +5426,9 @@
                 <a:solidFill>
                   <a:srgbClr val="A8A29E"/>
                 </a:solidFill>
-                <a:latin typeface="paybooc OTF" pitchFamily="34" charset="0"/>
-                <a:ea typeface="paybooc OTF" pitchFamily="34" charset="-122"/>
-                <a:cs typeface="paybooc OTF" pitchFamily="34" charset="-120"/>
+                <a:latin typeface="Pretendard Light" pitchFamily="34" charset="0"/>
+                <a:ea typeface="Pretendard Light" pitchFamily="34" charset="-122"/>
+                <a:cs typeface="Pretendard Light" pitchFamily="34" charset="-120"/>
               </a:rPr>
               <a:t>THE YEARLY LUCK</a:t>
             </a:r>
@@ -5659,9 +5659,9 @@
                 <a:solidFill>
                   <a:srgbClr val="0C0A09"/>
                 </a:solidFill>
-                <a:latin typeface="paybooc OTF" pitchFamily="34" charset="0"/>
-                <a:ea typeface="paybooc OTF" pitchFamily="34" charset="-122"/>
-                <a:cs typeface="paybooc OTF" pitchFamily="34" charset="-120"/>
+                <a:latin typeface="Pretendard Light" pitchFamily="34" charset="0"/>
+                <a:ea typeface="Pretendard Light" pitchFamily="34" charset="-122"/>
+                <a:cs typeface="Pretendard Light" pitchFamily="34" charset="-120"/>
               </a:rPr>
               <a:t>수수 사주교육</a:t>
             </a:r>
@@ -5697,9 +5697,9 @@
                 <a:solidFill>
                   <a:srgbClr val="777169"/>
                 </a:solidFill>
-                <a:latin typeface="paybooc OTF" pitchFamily="34" charset="0"/>
-                <a:ea typeface="paybooc OTF" pitchFamily="34" charset="-122"/>
-                <a:cs typeface="paybooc OTF" pitchFamily="34" charset="-120"/>
+                <a:latin typeface="Pretendard Light" pitchFamily="34" charset="0"/>
+                <a:ea typeface="Pretendard Light" pitchFamily="34" charset="-122"/>
+                <a:cs typeface="Pretendard Light" pitchFamily="34" charset="-120"/>
               </a:rPr>
               <a:t>03</a:t>
             </a:r>
@@ -5735,9 +5735,9 @@
                 <a:solidFill>
                   <a:srgbClr val="777169"/>
                 </a:solidFill>
-                <a:latin typeface="paybooc OTF" pitchFamily="34" charset="0"/>
-                <a:ea typeface="paybooc OTF" pitchFamily="34" charset="-122"/>
-                <a:cs typeface="paybooc OTF" pitchFamily="34" charset="-120"/>
+                <a:latin typeface="Pretendard Light" pitchFamily="34" charset="0"/>
+                <a:ea typeface="Pretendard Light" pitchFamily="34" charset="-122"/>
+                <a:cs typeface="Pretendard Light" pitchFamily="34" charset="-120"/>
               </a:rPr>
               <a:t>03 · 세운(歲運)</a:t>
             </a:r>
@@ -5811,9 +5811,9 @@
                 <a:solidFill>
                   <a:srgbClr val="777169"/>
                 </a:solidFill>
-                <a:latin typeface="paybooc OTF" pitchFamily="34" charset="0"/>
-                <a:ea typeface="paybooc OTF" pitchFamily="34" charset="-122"/>
-                <a:cs typeface="paybooc OTF" pitchFamily="34" charset="-120"/>
+                <a:latin typeface="Pretendard Light" pitchFamily="34" charset="0"/>
+                <a:ea typeface="Pretendard Light" pitchFamily="34" charset="-122"/>
+                <a:cs typeface="Pretendard Light" pitchFamily="34" charset="-120"/>
               </a:rPr>
               <a:t>매년 바뀌는 1년의 간지</a:t>
             </a:r>
@@ -5883,9 +5883,9 @@
                 <a:solidFill>
                   <a:srgbClr val="777169"/>
                 </a:solidFill>
-                <a:latin typeface="paybooc OTF" pitchFamily="34" charset="0"/>
-                <a:ea typeface="paybooc OTF" pitchFamily="34" charset="-122"/>
-                <a:cs typeface="paybooc OTF" pitchFamily="34" charset="-120"/>
+                <a:latin typeface="Pretendard Light" pitchFamily="34" charset="0"/>
+                <a:ea typeface="Pretendard Light" pitchFamily="34" charset="-122"/>
+                <a:cs typeface="Pretendard Light" pitchFamily="34" charset="-120"/>
               </a:rPr>
               <a:t>주기</a:t>
             </a:r>
@@ -5921,9 +5921,9 @@
                 <a:solidFill>
                   <a:srgbClr val="0C0A09"/>
                 </a:solidFill>
-                <a:latin typeface="paybooc OTF" pitchFamily="34" charset="0"/>
-                <a:ea typeface="paybooc OTF" pitchFamily="34" charset="-122"/>
-                <a:cs typeface="paybooc OTF" pitchFamily="34" charset="-120"/>
+                <a:latin typeface="Pretendard Light" pitchFamily="34" charset="0"/>
+                <a:ea typeface="Pretendard Light" pitchFamily="34" charset="-122"/>
+                <a:cs typeface="Pretendard Light" pitchFamily="34" charset="-120"/>
               </a:rPr>
               <a:t>1년 단위</a:t>
             </a:r>
@@ -6034,9 +6034,9 @@
                 <a:solidFill>
                   <a:srgbClr val="777169"/>
                 </a:solidFill>
-                <a:latin typeface="paybooc OTF" pitchFamily="34" charset="0"/>
-                <a:ea typeface="paybooc OTF" pitchFamily="34" charset="-122"/>
-                <a:cs typeface="paybooc OTF" pitchFamily="34" charset="-120"/>
+                <a:latin typeface="Pretendard Light" pitchFamily="34" charset="0"/>
+                <a:ea typeface="Pretendard Light" pitchFamily="34" charset="-122"/>
+                <a:cs typeface="Pretendard Light" pitchFamily="34" charset="-120"/>
               </a:rPr>
               <a:t>공통</a:t>
             </a:r>
@@ -6072,9 +6072,9 @@
                 <a:solidFill>
                   <a:srgbClr val="0C0A09"/>
                 </a:solidFill>
-                <a:latin typeface="paybooc OTF" pitchFamily="34" charset="0"/>
-                <a:ea typeface="paybooc OTF" pitchFamily="34" charset="-122"/>
-                <a:cs typeface="paybooc OTF" pitchFamily="34" charset="-120"/>
+                <a:latin typeface="Pretendard Light" pitchFamily="34" charset="0"/>
+                <a:ea typeface="Pretendard Light" pitchFamily="34" charset="-122"/>
+                <a:cs typeface="Pretendard Light" pitchFamily="34" charset="-120"/>
               </a:rPr>
               <a:t>모두에게 동일</a:t>
             </a:r>
@@ -6185,9 +6185,9 @@
                 <a:solidFill>
                   <a:srgbClr val="777169"/>
                 </a:solidFill>
-                <a:latin typeface="paybooc OTF" pitchFamily="34" charset="0"/>
-                <a:ea typeface="paybooc OTF" pitchFamily="34" charset="-122"/>
-                <a:cs typeface="paybooc OTF" pitchFamily="34" charset="-120"/>
+                <a:latin typeface="Pretendard Light" pitchFamily="34" charset="0"/>
+                <a:ea typeface="Pretendard Light" pitchFamily="34" charset="-122"/>
+                <a:cs typeface="Pretendard Light" pitchFamily="34" charset="-120"/>
               </a:rPr>
               <a:t>개인차</a:t>
             </a:r>
@@ -6223,9 +6223,9 @@
                 <a:solidFill>
                   <a:srgbClr val="0C0A09"/>
                 </a:solidFill>
-                <a:latin typeface="paybooc OTF" pitchFamily="34" charset="0"/>
-                <a:ea typeface="paybooc OTF" pitchFamily="34" charset="-122"/>
-                <a:cs typeface="paybooc OTF" pitchFamily="34" charset="-120"/>
+                <a:latin typeface="Pretendard Light" pitchFamily="34" charset="0"/>
+                <a:ea typeface="Pretendard Light" pitchFamily="34" charset="-122"/>
+                <a:cs typeface="Pretendard Light" pitchFamily="34" charset="-120"/>
               </a:rPr>
               <a:t>해석은 제각각</a:t>
             </a:r>
@@ -6336,9 +6336,9 @@
                 <a:solidFill>
                   <a:srgbClr val="777169"/>
                 </a:solidFill>
-                <a:latin typeface="paybooc OTF" pitchFamily="34" charset="0"/>
-                <a:ea typeface="paybooc OTF" pitchFamily="34" charset="-122"/>
-                <a:cs typeface="paybooc OTF" pitchFamily="34" charset="-120"/>
+                <a:latin typeface="Pretendard Light" pitchFamily="34" charset="0"/>
+                <a:ea typeface="Pretendard Light" pitchFamily="34" charset="-122"/>
+                <a:cs typeface="Pretendard Light" pitchFamily="34" charset="-120"/>
               </a:rPr>
               <a:t>올해 예시</a:t>
             </a:r>
@@ -6591,9 +6591,9 @@
                 <a:solidFill>
                   <a:srgbClr val="0C0A09"/>
                 </a:solidFill>
-                <a:latin typeface="paybooc OTF" pitchFamily="34" charset="0"/>
-                <a:ea typeface="paybooc OTF" pitchFamily="34" charset="-122"/>
-                <a:cs typeface="paybooc OTF" pitchFamily="34" charset="-120"/>
+                <a:latin typeface="Pretendard Light" pitchFamily="34" charset="0"/>
+                <a:ea typeface="Pretendard Light" pitchFamily="34" charset="-122"/>
+                <a:cs typeface="Pretendard Light" pitchFamily="34" charset="-120"/>
               </a:rPr>
               <a:t>수수 사주교육</a:t>
             </a:r>
@@ -6629,9 +6629,9 @@
                 <a:solidFill>
                   <a:srgbClr val="777169"/>
                 </a:solidFill>
-                <a:latin typeface="paybooc OTF" pitchFamily="34" charset="0"/>
-                <a:ea typeface="paybooc OTF" pitchFamily="34" charset="-122"/>
-                <a:cs typeface="paybooc OTF" pitchFamily="34" charset="-120"/>
+                <a:latin typeface="Pretendard Light" pitchFamily="34" charset="0"/>
+                <a:ea typeface="Pretendard Light" pitchFamily="34" charset="-122"/>
+                <a:cs typeface="Pretendard Light" pitchFamily="34" charset="-120"/>
               </a:rPr>
               <a:t>03</a:t>
             </a:r>
@@ -6667,9 +6667,9 @@
                 <a:solidFill>
                   <a:srgbClr val="777169"/>
                 </a:solidFill>
-                <a:latin typeface="paybooc OTF" pitchFamily="34" charset="0"/>
-                <a:ea typeface="paybooc OTF" pitchFamily="34" charset="-122"/>
-                <a:cs typeface="paybooc OTF" pitchFamily="34" charset="-120"/>
+                <a:latin typeface="Pretendard Light" pitchFamily="34" charset="0"/>
+                <a:ea typeface="Pretendard Light" pitchFamily="34" charset="-122"/>
+                <a:cs typeface="Pretendard Light" pitchFamily="34" charset="-120"/>
               </a:rPr>
               <a:t>03 · 세운(歲運)</a:t>
             </a:r>
@@ -6743,9 +6743,9 @@
                 <a:solidFill>
                   <a:srgbClr val="777169"/>
                 </a:solidFill>
-                <a:latin typeface="paybooc OTF" pitchFamily="34" charset="0"/>
-                <a:ea typeface="paybooc OTF" pitchFamily="34" charset="-122"/>
-                <a:cs typeface="paybooc OTF" pitchFamily="34" charset="-120"/>
+                <a:latin typeface="Pretendard Light" pitchFamily="34" charset="0"/>
+                <a:ea typeface="Pretendard Light" pitchFamily="34" charset="-122"/>
+                <a:cs typeface="Pretendard Light" pitchFamily="34" charset="-120"/>
               </a:rPr>
               <a:t>무대냐, 사건이냐</a:t>
             </a:r>
@@ -6815,9 +6815,9 @@
                 <a:solidFill>
                   <a:srgbClr val="0C0A09"/>
                 </a:solidFill>
-                <a:latin typeface="paybooc OTF" pitchFamily="34" charset="0"/>
-                <a:ea typeface="paybooc OTF" pitchFamily="34" charset="-122"/>
-                <a:cs typeface="paybooc OTF" pitchFamily="34" charset="-120"/>
+                <a:latin typeface="Pretendard Light" pitchFamily="34" charset="0"/>
+                <a:ea typeface="Pretendard Light" pitchFamily="34" charset="-122"/>
+                <a:cs typeface="Pretendard Light" pitchFamily="34" charset="-120"/>
               </a:rPr>
               <a:t>구분</a:t>
             </a:r>
@@ -6853,9 +6853,9 @@
                 <a:solidFill>
                   <a:srgbClr val="0C0A09"/>
                 </a:solidFill>
-                <a:latin typeface="paybooc OTF" pitchFamily="34" charset="0"/>
-                <a:ea typeface="paybooc OTF" pitchFamily="34" charset="-122"/>
-                <a:cs typeface="paybooc OTF" pitchFamily="34" charset="-120"/>
+                <a:latin typeface="Pretendard Light" pitchFamily="34" charset="0"/>
+                <a:ea typeface="Pretendard Light" pitchFamily="34" charset="-122"/>
+                <a:cs typeface="Pretendard Light" pitchFamily="34" charset="-120"/>
               </a:rPr>
               <a:t>대운(大運)</a:t>
             </a:r>
@@ -6891,9 +6891,9 @@
                 <a:solidFill>
                   <a:srgbClr val="0C0A09"/>
                 </a:solidFill>
-                <a:latin typeface="paybooc OTF" pitchFamily="34" charset="0"/>
-                <a:ea typeface="paybooc OTF" pitchFamily="34" charset="-122"/>
-                <a:cs typeface="paybooc OTF" pitchFamily="34" charset="-120"/>
+                <a:latin typeface="Pretendard Light" pitchFamily="34" charset="0"/>
+                <a:ea typeface="Pretendard Light" pitchFamily="34" charset="-122"/>
+                <a:cs typeface="Pretendard Light" pitchFamily="34" charset="-120"/>
               </a:rPr>
               <a:t>세운(歲運)</a:t>
             </a:r>
@@ -6955,9 +6955,9 @@
                 <a:solidFill>
                   <a:srgbClr val="292524"/>
                 </a:solidFill>
-                <a:latin typeface="paybooc OTF" pitchFamily="34" charset="0"/>
-                <a:ea typeface="paybooc OTF" pitchFamily="34" charset="-122"/>
-                <a:cs typeface="paybooc OTF" pitchFamily="34" charset="-120"/>
+                <a:latin typeface="Pretendard Light" pitchFamily="34" charset="0"/>
+                <a:ea typeface="Pretendard Light" pitchFamily="34" charset="-122"/>
+                <a:cs typeface="Pretendard Light" pitchFamily="34" charset="-120"/>
               </a:rPr>
               <a:t>주기</a:t>
             </a:r>
@@ -7101,9 +7101,9 @@
                 <a:solidFill>
                   <a:srgbClr val="292524"/>
                 </a:solidFill>
-                <a:latin typeface="paybooc OTF" pitchFamily="34" charset="0"/>
-                <a:ea typeface="paybooc OTF" pitchFamily="34" charset="-122"/>
-                <a:cs typeface="paybooc OTF" pitchFamily="34" charset="-120"/>
+                <a:latin typeface="Pretendard Light" pitchFamily="34" charset="0"/>
+                <a:ea typeface="Pretendard Light" pitchFamily="34" charset="-122"/>
+                <a:cs typeface="Pretendard Light" pitchFamily="34" charset="-120"/>
               </a:rPr>
               <a:t>역할</a:t>
             </a:r>
@@ -7247,9 +7247,9 @@
                 <a:solidFill>
                   <a:srgbClr val="292524"/>
                 </a:solidFill>
-                <a:latin typeface="paybooc OTF" pitchFamily="34" charset="0"/>
-                <a:ea typeface="paybooc OTF" pitchFamily="34" charset="-122"/>
-                <a:cs typeface="paybooc OTF" pitchFamily="34" charset="-120"/>
+                <a:latin typeface="Pretendard Light" pitchFamily="34" charset="0"/>
+                <a:ea typeface="Pretendard Light" pitchFamily="34" charset="-122"/>
+                <a:cs typeface="Pretendard Light" pitchFamily="34" charset="-120"/>
               </a:rPr>
               <a:t>비유</a:t>
             </a:r>
@@ -7393,9 +7393,9 @@
                 <a:solidFill>
                   <a:srgbClr val="292524"/>
                 </a:solidFill>
-                <a:latin typeface="paybooc OTF" pitchFamily="34" charset="0"/>
-                <a:ea typeface="paybooc OTF" pitchFamily="34" charset="-122"/>
-                <a:cs typeface="paybooc OTF" pitchFamily="34" charset="-120"/>
+                <a:latin typeface="Pretendard Light" pitchFamily="34" charset="0"/>
+                <a:ea typeface="Pretendard Light" pitchFamily="34" charset="-122"/>
+                <a:cs typeface="Pretendard Light" pitchFamily="34" charset="-120"/>
               </a:rPr>
               <a:t>바뀜</a:t>
             </a:r>
@@ -7539,9 +7539,9 @@
                 <a:solidFill>
                   <a:srgbClr val="292524"/>
                 </a:solidFill>
-                <a:latin typeface="paybooc OTF" pitchFamily="34" charset="0"/>
-                <a:ea typeface="paybooc OTF" pitchFamily="34" charset="-122"/>
-                <a:cs typeface="paybooc OTF" pitchFamily="34" charset="-120"/>
+                <a:latin typeface="Pretendard Light" pitchFamily="34" charset="0"/>
+                <a:ea typeface="Pretendard Light" pitchFamily="34" charset="-122"/>
+                <a:cs typeface="Pretendard Light" pitchFamily="34" charset="-120"/>
               </a:rPr>
               <a:t>관점</a:t>
             </a:r>
@@ -7859,9 +7859,9 @@
                 <a:solidFill>
                   <a:srgbClr val="0C0A09"/>
                 </a:solidFill>
-                <a:latin typeface="paybooc OTF" pitchFamily="34" charset="0"/>
-                <a:ea typeface="paybooc OTF" pitchFamily="34" charset="-122"/>
-                <a:cs typeface="paybooc OTF" pitchFamily="34" charset="-120"/>
+                <a:latin typeface="Pretendard Light" pitchFamily="34" charset="0"/>
+                <a:ea typeface="Pretendard Light" pitchFamily="34" charset="-122"/>
+                <a:cs typeface="Pretendard Light" pitchFamily="34" charset="-120"/>
               </a:rPr>
               <a:t>수수 사주교육</a:t>
             </a:r>
@@ -7897,9 +7897,9 @@
                 <a:solidFill>
                   <a:srgbClr val="777169"/>
                 </a:solidFill>
-                <a:latin typeface="paybooc OTF" pitchFamily="34" charset="0"/>
-                <a:ea typeface="paybooc OTF" pitchFamily="34" charset="-122"/>
-                <a:cs typeface="paybooc OTF" pitchFamily="34" charset="-120"/>
+                <a:latin typeface="Pretendard Light" pitchFamily="34" charset="0"/>
+                <a:ea typeface="Pretendard Light" pitchFamily="34" charset="-122"/>
+                <a:cs typeface="Pretendard Light" pitchFamily="34" charset="-120"/>
               </a:rPr>
               <a:t>03</a:t>
             </a:r>
@@ -7935,9 +7935,9 @@
                 <a:solidFill>
                   <a:srgbClr val="777169"/>
                 </a:solidFill>
-                <a:latin typeface="paybooc OTF" pitchFamily="34" charset="0"/>
-                <a:ea typeface="paybooc OTF" pitchFamily="34" charset="-122"/>
-                <a:cs typeface="paybooc OTF" pitchFamily="34" charset="-120"/>
+                <a:latin typeface="Pretendard Light" pitchFamily="34" charset="0"/>
+                <a:ea typeface="Pretendard Light" pitchFamily="34" charset="-122"/>
+                <a:cs typeface="Pretendard Light" pitchFamily="34" charset="-120"/>
               </a:rPr>
               <a:t>03 · 세운(歲運)</a:t>
             </a:r>
@@ -8011,9 +8011,9 @@
                 <a:solidFill>
                   <a:srgbClr val="777169"/>
                 </a:solidFill>
-                <a:latin typeface="paybooc OTF" pitchFamily="34" charset="0"/>
-                <a:ea typeface="paybooc OTF" pitchFamily="34" charset="-122"/>
-                <a:cs typeface="paybooc OTF" pitchFamily="34" charset="-120"/>
+                <a:latin typeface="Pretendard Light" pitchFamily="34" charset="0"/>
+                <a:ea typeface="Pretendard Light" pitchFamily="34" charset="-122"/>
+                <a:cs typeface="Pretendard Light" pitchFamily="34" charset="-120"/>
               </a:rPr>
               <a:t>1년을 다시 12달로 쪼갠다</a:t>
             </a:r>
@@ -8083,9 +8083,9 @@
                 <a:solidFill>
                   <a:srgbClr val="4E4E4E"/>
                 </a:solidFill>
-                <a:latin typeface="paybooc OTF" pitchFamily="34" charset="0"/>
-                <a:ea typeface="paybooc OTF" pitchFamily="34" charset="-122"/>
-                <a:cs typeface="paybooc OTF" pitchFamily="34" charset="-120"/>
+                <a:latin typeface="Pretendard Light" pitchFamily="34" charset="0"/>
+                <a:ea typeface="Pretendard Light" pitchFamily="34" charset="-122"/>
+                <a:cs typeface="Pretendard Light" pitchFamily="34" charset="-120"/>
               </a:rPr>
               <a:t>1월</a:t>
             </a:r>
@@ -8155,9 +8155,9 @@
                 <a:solidFill>
                   <a:srgbClr val="4E4E4E"/>
                 </a:solidFill>
-                <a:latin typeface="paybooc OTF" pitchFamily="34" charset="0"/>
-                <a:ea typeface="paybooc OTF" pitchFamily="34" charset="-122"/>
-                <a:cs typeface="paybooc OTF" pitchFamily="34" charset="-120"/>
+                <a:latin typeface="Pretendard Light" pitchFamily="34" charset="0"/>
+                <a:ea typeface="Pretendard Light" pitchFamily="34" charset="-122"/>
+                <a:cs typeface="Pretendard Light" pitchFamily="34" charset="-120"/>
               </a:rPr>
               <a:t>2월</a:t>
             </a:r>
@@ -8227,9 +8227,9 @@
                 <a:solidFill>
                   <a:srgbClr val="4E4E4E"/>
                 </a:solidFill>
-                <a:latin typeface="paybooc OTF" pitchFamily="34" charset="0"/>
-                <a:ea typeface="paybooc OTF" pitchFamily="34" charset="-122"/>
-                <a:cs typeface="paybooc OTF" pitchFamily="34" charset="-120"/>
+                <a:latin typeface="Pretendard Light" pitchFamily="34" charset="0"/>
+                <a:ea typeface="Pretendard Light" pitchFamily="34" charset="-122"/>
+                <a:cs typeface="Pretendard Light" pitchFamily="34" charset="-120"/>
               </a:rPr>
               <a:t>3월</a:t>
             </a:r>
@@ -8299,9 +8299,9 @@
                 <a:solidFill>
                   <a:srgbClr val="4E4E4E"/>
                 </a:solidFill>
-                <a:latin typeface="paybooc OTF" pitchFamily="34" charset="0"/>
-                <a:ea typeface="paybooc OTF" pitchFamily="34" charset="-122"/>
-                <a:cs typeface="paybooc OTF" pitchFamily="34" charset="-120"/>
+                <a:latin typeface="Pretendard Light" pitchFamily="34" charset="0"/>
+                <a:ea typeface="Pretendard Light" pitchFamily="34" charset="-122"/>
+                <a:cs typeface="Pretendard Light" pitchFamily="34" charset="-120"/>
               </a:rPr>
               <a:t>4월</a:t>
             </a:r>
@@ -8371,9 +8371,9 @@
                 <a:solidFill>
                   <a:srgbClr val="4E4E4E"/>
                 </a:solidFill>
-                <a:latin typeface="paybooc OTF" pitchFamily="34" charset="0"/>
-                <a:ea typeface="paybooc OTF" pitchFamily="34" charset="-122"/>
-                <a:cs typeface="paybooc OTF" pitchFamily="34" charset="-120"/>
+                <a:latin typeface="Pretendard Light" pitchFamily="34" charset="0"/>
+                <a:ea typeface="Pretendard Light" pitchFamily="34" charset="-122"/>
+                <a:cs typeface="Pretendard Light" pitchFamily="34" charset="-120"/>
               </a:rPr>
               <a:t>5월</a:t>
             </a:r>
@@ -8443,9 +8443,9 @@
                 <a:solidFill>
                   <a:srgbClr val="0C0A09"/>
                 </a:solidFill>
-                <a:latin typeface="paybooc OTF" pitchFamily="34" charset="0"/>
-                <a:ea typeface="paybooc OTF" pitchFamily="34" charset="-122"/>
-                <a:cs typeface="paybooc OTF" pitchFamily="34" charset="-120"/>
+                <a:latin typeface="Pretendard Light" pitchFamily="34" charset="0"/>
+                <a:ea typeface="Pretendard Light" pitchFamily="34" charset="-122"/>
+                <a:cs typeface="Pretendard Light" pitchFamily="34" charset="-120"/>
               </a:rPr>
               <a:t>6월</a:t>
             </a:r>
@@ -8515,9 +8515,9 @@
                 <a:solidFill>
                   <a:srgbClr val="4E4E4E"/>
                 </a:solidFill>
-                <a:latin typeface="paybooc OTF" pitchFamily="34" charset="0"/>
-                <a:ea typeface="paybooc OTF" pitchFamily="34" charset="-122"/>
-                <a:cs typeface="paybooc OTF" pitchFamily="34" charset="-120"/>
+                <a:latin typeface="Pretendard Light" pitchFamily="34" charset="0"/>
+                <a:ea typeface="Pretendard Light" pitchFamily="34" charset="-122"/>
+                <a:cs typeface="Pretendard Light" pitchFamily="34" charset="-120"/>
               </a:rPr>
               <a:t>7월</a:t>
             </a:r>
@@ -8587,9 +8587,9 @@
                 <a:solidFill>
                   <a:srgbClr val="4E4E4E"/>
                 </a:solidFill>
-                <a:latin typeface="paybooc OTF" pitchFamily="34" charset="0"/>
-                <a:ea typeface="paybooc OTF" pitchFamily="34" charset="-122"/>
-                <a:cs typeface="paybooc OTF" pitchFamily="34" charset="-120"/>
+                <a:latin typeface="Pretendard Light" pitchFamily="34" charset="0"/>
+                <a:ea typeface="Pretendard Light" pitchFamily="34" charset="-122"/>
+                <a:cs typeface="Pretendard Light" pitchFamily="34" charset="-120"/>
               </a:rPr>
               <a:t>8월</a:t>
             </a:r>
@@ -8659,9 +8659,9 @@
                 <a:solidFill>
                   <a:srgbClr val="4E4E4E"/>
                 </a:solidFill>
-                <a:latin typeface="paybooc OTF" pitchFamily="34" charset="0"/>
-                <a:ea typeface="paybooc OTF" pitchFamily="34" charset="-122"/>
-                <a:cs typeface="paybooc OTF" pitchFamily="34" charset="-120"/>
+                <a:latin typeface="Pretendard Light" pitchFamily="34" charset="0"/>
+                <a:ea typeface="Pretendard Light" pitchFamily="34" charset="-122"/>
+                <a:cs typeface="Pretendard Light" pitchFamily="34" charset="-120"/>
               </a:rPr>
               <a:t>9월</a:t>
             </a:r>
@@ -8731,9 +8731,9 @@
                 <a:solidFill>
                   <a:srgbClr val="4E4E4E"/>
                 </a:solidFill>
-                <a:latin typeface="paybooc OTF" pitchFamily="34" charset="0"/>
-                <a:ea typeface="paybooc OTF" pitchFamily="34" charset="-122"/>
-                <a:cs typeface="paybooc OTF" pitchFamily="34" charset="-120"/>
+                <a:latin typeface="Pretendard Light" pitchFamily="34" charset="0"/>
+                <a:ea typeface="Pretendard Light" pitchFamily="34" charset="-122"/>
+                <a:cs typeface="Pretendard Light" pitchFamily="34" charset="-120"/>
               </a:rPr>
               <a:t>10월</a:t>
             </a:r>
@@ -8803,9 +8803,9 @@
                 <a:solidFill>
                   <a:srgbClr val="4E4E4E"/>
                 </a:solidFill>
-                <a:latin typeface="paybooc OTF" pitchFamily="34" charset="0"/>
-                <a:ea typeface="paybooc OTF" pitchFamily="34" charset="-122"/>
-                <a:cs typeface="paybooc OTF" pitchFamily="34" charset="-120"/>
+                <a:latin typeface="Pretendard Light" pitchFamily="34" charset="0"/>
+                <a:ea typeface="Pretendard Light" pitchFamily="34" charset="-122"/>
+                <a:cs typeface="Pretendard Light" pitchFamily="34" charset="-120"/>
               </a:rPr>
               <a:t>11월</a:t>
             </a:r>
@@ -8875,9 +8875,9 @@
                 <a:solidFill>
                   <a:srgbClr val="4E4E4E"/>
                 </a:solidFill>
-                <a:latin typeface="paybooc OTF" pitchFamily="34" charset="0"/>
-                <a:ea typeface="paybooc OTF" pitchFamily="34" charset="-122"/>
-                <a:cs typeface="paybooc OTF" pitchFamily="34" charset="-120"/>
+                <a:latin typeface="Pretendard Light" pitchFamily="34" charset="0"/>
+                <a:ea typeface="Pretendard Light" pitchFamily="34" charset="-122"/>
+                <a:cs typeface="Pretendard Light" pitchFamily="34" charset="-120"/>
               </a:rPr>
               <a:t>12월</a:t>
             </a:r>
@@ -8947,9 +8947,9 @@
                 <a:solidFill>
                   <a:srgbClr val="777169"/>
                 </a:solidFill>
-                <a:latin typeface="paybooc OTF" pitchFamily="34" charset="0"/>
-                <a:ea typeface="paybooc OTF" pitchFamily="34" charset="-122"/>
-                <a:cs typeface="paybooc OTF" pitchFamily="34" charset="-120"/>
+                <a:latin typeface="Pretendard Light" pitchFamily="34" charset="0"/>
+                <a:ea typeface="Pretendard Light" pitchFamily="34" charset="-122"/>
+                <a:cs typeface="Pretendard Light" pitchFamily="34" charset="-120"/>
               </a:rPr>
               <a:t>쓰임</a:t>
             </a:r>
@@ -9221,9 +9221,9 @@
                 <a:solidFill>
                   <a:srgbClr val="0C0A09"/>
                 </a:solidFill>
-                <a:latin typeface="paybooc OTF" pitchFamily="34" charset="0"/>
-                <a:ea typeface="paybooc OTF" pitchFamily="34" charset="-122"/>
-                <a:cs typeface="paybooc OTF" pitchFamily="34" charset="-120"/>
+                <a:latin typeface="Pretendard Light" pitchFamily="34" charset="0"/>
+                <a:ea typeface="Pretendard Light" pitchFamily="34" charset="-122"/>
+                <a:cs typeface="Pretendard Light" pitchFamily="34" charset="-120"/>
               </a:rPr>
               <a:t>수수 사주교육</a:t>
             </a:r>
@@ -9259,9 +9259,9 @@
                 <a:solidFill>
                   <a:srgbClr val="777169"/>
                 </a:solidFill>
-                <a:latin typeface="paybooc OTF" pitchFamily="34" charset="0"/>
-                <a:ea typeface="paybooc OTF" pitchFamily="34" charset="-122"/>
-                <a:cs typeface="paybooc OTF" pitchFamily="34" charset="-120"/>
+                <a:latin typeface="Pretendard Light" pitchFamily="34" charset="0"/>
+                <a:ea typeface="Pretendard Light" pitchFamily="34" charset="-122"/>
+                <a:cs typeface="Pretendard Light" pitchFamily="34" charset="-120"/>
               </a:rPr>
               <a:t>SECTION 04</a:t>
             </a:r>
@@ -9297,9 +9297,9 @@
                 <a:solidFill>
                   <a:srgbClr val="777169"/>
                 </a:solidFill>
-                <a:latin typeface="paybooc OTF" pitchFamily="34" charset="0"/>
-                <a:ea typeface="paybooc OTF" pitchFamily="34" charset="-122"/>
-                <a:cs typeface="paybooc OTF" pitchFamily="34" charset="-120"/>
+                <a:latin typeface="Pretendard Light" pitchFamily="34" charset="0"/>
+                <a:ea typeface="Pretendard Light" pitchFamily="34" charset="-122"/>
+                <a:cs typeface="Pretendard Light" pitchFamily="34" charset="-120"/>
               </a:rPr>
               <a:t>SECTION 04</a:t>
             </a:r>
@@ -9373,9 +9373,9 @@
                 <a:solidFill>
                   <a:srgbClr val="A8A29E"/>
                 </a:solidFill>
-                <a:latin typeface="paybooc OTF" pitchFamily="34" charset="0"/>
-                <a:ea typeface="paybooc OTF" pitchFamily="34" charset="-122"/>
-                <a:cs typeface="paybooc OTF" pitchFamily="34" charset="-120"/>
+                <a:latin typeface="Pretendard Light" pitchFamily="34" charset="0"/>
+                <a:ea typeface="Pretendard Light" pitchFamily="34" charset="-122"/>
+                <a:cs typeface="Pretendard Light" pitchFamily="34" charset="-120"/>
               </a:rPr>
               <a:t>READING THE CHART · 실습</a:t>
             </a:r>
@@ -9606,9 +9606,9 @@
                 <a:solidFill>
                   <a:srgbClr val="0C0A09"/>
                 </a:solidFill>
-                <a:latin typeface="paybooc OTF" pitchFamily="34" charset="0"/>
-                <a:ea typeface="paybooc OTF" pitchFamily="34" charset="-122"/>
-                <a:cs typeface="paybooc OTF" pitchFamily="34" charset="-120"/>
+                <a:latin typeface="Pretendard Light" pitchFamily="34" charset="0"/>
+                <a:ea typeface="Pretendard Light" pitchFamily="34" charset="-122"/>
+                <a:cs typeface="Pretendard Light" pitchFamily="34" charset="-120"/>
               </a:rPr>
               <a:t>수수 사주교육</a:t>
             </a:r>
@@ -9644,9 +9644,9 @@
                 <a:solidFill>
                   <a:srgbClr val="777169"/>
                 </a:solidFill>
-                <a:latin typeface="paybooc OTF" pitchFamily="34" charset="0"/>
-                <a:ea typeface="paybooc OTF" pitchFamily="34" charset="-122"/>
-                <a:cs typeface="paybooc OTF" pitchFamily="34" charset="-120"/>
+                <a:latin typeface="Pretendard Light" pitchFamily="34" charset="0"/>
+                <a:ea typeface="Pretendard Light" pitchFamily="34" charset="-122"/>
+                <a:cs typeface="Pretendard Light" pitchFamily="34" charset="-120"/>
               </a:rPr>
               <a:t>AGENDA</a:t>
             </a:r>
@@ -9682,9 +9682,9 @@
                 <a:solidFill>
                   <a:srgbClr val="777169"/>
                 </a:solidFill>
-                <a:latin typeface="paybooc OTF" pitchFamily="34" charset="0"/>
-                <a:ea typeface="paybooc OTF" pitchFamily="34" charset="-122"/>
-                <a:cs typeface="paybooc OTF" pitchFamily="34" charset="-120"/>
+                <a:latin typeface="Pretendard Light" pitchFamily="34" charset="0"/>
+                <a:ea typeface="Pretendard Light" pitchFamily="34" charset="-122"/>
+                <a:cs typeface="Pretendard Light" pitchFamily="34" charset="-120"/>
               </a:rPr>
               <a:t>COURSE OVERVIEW</a:t>
             </a:r>
@@ -9758,9 +9758,9 @@
                 <a:solidFill>
                   <a:srgbClr val="777169"/>
                 </a:solidFill>
-                <a:latin typeface="paybooc OTF" pitchFamily="34" charset="0"/>
-                <a:ea typeface="paybooc OTF" pitchFamily="34" charset="-122"/>
-                <a:cs typeface="paybooc OTF" pitchFamily="34" charset="-120"/>
+                <a:latin typeface="Pretendard Light" pitchFamily="34" charset="0"/>
+                <a:ea typeface="Pretendard Light" pitchFamily="34" charset="-122"/>
+                <a:cs typeface="Pretendard Light" pitchFamily="34" charset="-120"/>
               </a:rPr>
               <a:t>오늘 따라갈 다섯 개의 흐름</a:t>
             </a:r>
@@ -9856,9 +9856,9 @@
                 <a:solidFill>
                   <a:srgbClr val="0C0A09"/>
                 </a:solidFill>
-                <a:latin typeface="paybooc OTF" pitchFamily="34" charset="0"/>
-                <a:ea typeface="paybooc OTF" pitchFamily="34" charset="-122"/>
-                <a:cs typeface="paybooc OTF" pitchFamily="34" charset="-120"/>
+                <a:latin typeface="Pretendard Light" pitchFamily="34" charset="0"/>
+                <a:ea typeface="Pretendard Light" pitchFamily="34" charset="-122"/>
+                <a:cs typeface="Pretendard Light" pitchFamily="34" charset="-120"/>
               </a:rPr>
               <a:t>사주와 운의 관계</a:t>
             </a:r>
@@ -10015,9 +10015,9 @@
                 <a:solidFill>
                   <a:srgbClr val="0C0A09"/>
                 </a:solidFill>
-                <a:latin typeface="paybooc OTF" pitchFamily="34" charset="0"/>
-                <a:ea typeface="paybooc OTF" pitchFamily="34" charset="-122"/>
-                <a:cs typeface="paybooc OTF" pitchFamily="34" charset="-120"/>
+                <a:latin typeface="Pretendard Light" pitchFamily="34" charset="0"/>
+                <a:ea typeface="Pretendard Light" pitchFamily="34" charset="-122"/>
+                <a:cs typeface="Pretendard Light" pitchFamily="34" charset="-120"/>
               </a:rPr>
               <a:t>대운(大運)</a:t>
             </a:r>
@@ -10174,9 +10174,9 @@
                 <a:solidFill>
                   <a:srgbClr val="0C0A09"/>
                 </a:solidFill>
-                <a:latin typeface="paybooc OTF" pitchFamily="34" charset="0"/>
-                <a:ea typeface="paybooc OTF" pitchFamily="34" charset="-122"/>
-                <a:cs typeface="paybooc OTF" pitchFamily="34" charset="-120"/>
+                <a:latin typeface="Pretendard Light" pitchFamily="34" charset="0"/>
+                <a:ea typeface="Pretendard Light" pitchFamily="34" charset="-122"/>
+                <a:cs typeface="Pretendard Light" pitchFamily="34" charset="-120"/>
               </a:rPr>
               <a:t>세운(歲運)</a:t>
             </a:r>
@@ -10333,9 +10333,9 @@
                 <a:solidFill>
                   <a:srgbClr val="0C0A09"/>
                 </a:solidFill>
-                <a:latin typeface="paybooc OTF" pitchFamily="34" charset="0"/>
-                <a:ea typeface="paybooc OTF" pitchFamily="34" charset="-122"/>
-                <a:cs typeface="paybooc OTF" pitchFamily="34" charset="-120"/>
+                <a:latin typeface="Pretendard Light" pitchFamily="34" charset="0"/>
+                <a:ea typeface="Pretendard Light" pitchFamily="34" charset="-122"/>
+                <a:cs typeface="Pretendard Light" pitchFamily="34" charset="-120"/>
               </a:rPr>
               <a:t>만세력으로 직접 읽기</a:t>
             </a:r>
@@ -10492,9 +10492,9 @@
                 <a:solidFill>
                   <a:srgbClr val="0C0A09"/>
                 </a:solidFill>
-                <a:latin typeface="paybooc OTF" pitchFamily="34" charset="0"/>
-                <a:ea typeface="paybooc OTF" pitchFamily="34" charset="-122"/>
-                <a:cs typeface="paybooc OTF" pitchFamily="34" charset="-120"/>
+                <a:latin typeface="Pretendard Light" pitchFamily="34" charset="0"/>
+                <a:ea typeface="Pretendard Light" pitchFamily="34" charset="-122"/>
+                <a:cs typeface="Pretendard Light" pitchFamily="34" charset="-120"/>
               </a:rPr>
               <a:t>운 해석의 기초</a:t>
             </a:r>
@@ -10722,9 +10722,9 @@
                 <a:solidFill>
                   <a:srgbClr val="0C0A09"/>
                 </a:solidFill>
-                <a:latin typeface="paybooc OTF" pitchFamily="34" charset="0"/>
-                <a:ea typeface="paybooc OTF" pitchFamily="34" charset="-122"/>
-                <a:cs typeface="paybooc OTF" pitchFamily="34" charset="-120"/>
+                <a:latin typeface="Pretendard Light" pitchFamily="34" charset="0"/>
+                <a:ea typeface="Pretendard Light" pitchFamily="34" charset="-122"/>
+                <a:cs typeface="Pretendard Light" pitchFamily="34" charset="-120"/>
               </a:rPr>
               <a:t>수수 사주교육</a:t>
             </a:r>
@@ -10760,9 +10760,9 @@
                 <a:solidFill>
                   <a:srgbClr val="777169"/>
                 </a:solidFill>
-                <a:latin typeface="paybooc OTF" pitchFamily="34" charset="0"/>
-                <a:ea typeface="paybooc OTF" pitchFamily="34" charset="-122"/>
-                <a:cs typeface="paybooc OTF" pitchFamily="34" charset="-120"/>
+                <a:latin typeface="Pretendard Light" pitchFamily="34" charset="0"/>
+                <a:ea typeface="Pretendard Light" pitchFamily="34" charset="-122"/>
+                <a:cs typeface="Pretendard Light" pitchFamily="34" charset="-120"/>
               </a:rPr>
               <a:t>04</a:t>
             </a:r>
@@ -10798,9 +10798,9 @@
                 <a:solidFill>
                   <a:srgbClr val="777169"/>
                 </a:solidFill>
-                <a:latin typeface="paybooc OTF" pitchFamily="34" charset="0"/>
-                <a:ea typeface="paybooc OTF" pitchFamily="34" charset="-122"/>
-                <a:cs typeface="paybooc OTF" pitchFamily="34" charset="-120"/>
+                <a:latin typeface="Pretendard Light" pitchFamily="34" charset="0"/>
+                <a:ea typeface="Pretendard Light" pitchFamily="34" charset="-122"/>
+                <a:cs typeface="Pretendard Light" pitchFamily="34" charset="-120"/>
               </a:rPr>
               <a:t>04 · 만세력으로 직접 읽기</a:t>
             </a:r>
@@ -10874,9 +10874,9 @@
                 <a:solidFill>
                   <a:srgbClr val="777169"/>
                 </a:solidFill>
-                <a:latin typeface="paybooc OTF" pitchFamily="34" charset="0"/>
-                <a:ea typeface="paybooc OTF" pitchFamily="34" charset="-122"/>
-                <a:cs typeface="paybooc OTF" pitchFamily="34" charset="-120"/>
+                <a:latin typeface="Pretendard Light" pitchFamily="34" charset="0"/>
+                <a:ea typeface="Pretendard Light" pitchFamily="34" charset="-122"/>
+                <a:cs typeface="Pretendard Light" pitchFamily="34" charset="-120"/>
               </a:rPr>
               <a:t>원국 · 대운 · 세운의 위치 (예시 화면)</a:t>
             </a:r>
@@ -11006,9 +11006,9 @@
                 <a:solidFill>
                   <a:srgbClr val="0C0A09"/>
                 </a:solidFill>
-                <a:latin typeface="paybooc OTF" pitchFamily="34" charset="0"/>
-                <a:ea typeface="paybooc OTF" pitchFamily="34" charset="-122"/>
-                <a:cs typeface="paybooc OTF" pitchFamily="34" charset="-120"/>
+                <a:latin typeface="Pretendard Light" pitchFamily="34" charset="0"/>
+                <a:ea typeface="Pretendard Light" pitchFamily="34" charset="-122"/>
+                <a:cs typeface="Pretendard Light" pitchFamily="34" charset="-120"/>
               </a:rPr>
               <a:t>원국 (사주팔자)</a:t>
             </a:r>
@@ -11706,9 +11706,9 @@
                 <a:solidFill>
                   <a:srgbClr val="0C0A09"/>
                 </a:solidFill>
-                <a:latin typeface="paybooc OTF" pitchFamily="34" charset="0"/>
-                <a:ea typeface="paybooc OTF" pitchFamily="34" charset="-122"/>
-                <a:cs typeface="paybooc OTF" pitchFamily="34" charset="-120"/>
+                <a:latin typeface="Pretendard Light" pitchFamily="34" charset="0"/>
+                <a:ea typeface="Pretendard Light" pitchFamily="34" charset="-122"/>
+                <a:cs typeface="Pretendard Light" pitchFamily="34" charset="-120"/>
               </a:rPr>
               <a:t>대운 (10년 단위)</a:t>
             </a:r>
@@ -12357,9 +12357,9 @@
                 <a:solidFill>
                   <a:srgbClr val="0C0A09"/>
                 </a:solidFill>
-                <a:latin typeface="paybooc OTF" pitchFamily="34" charset="0"/>
-                <a:ea typeface="paybooc OTF" pitchFamily="34" charset="-122"/>
-                <a:cs typeface="paybooc OTF" pitchFamily="34" charset="-120"/>
+                <a:latin typeface="Pretendard Light" pitchFamily="34" charset="0"/>
+                <a:ea typeface="Pretendard Light" pitchFamily="34" charset="-122"/>
+                <a:cs typeface="Pretendard Light" pitchFamily="34" charset="-120"/>
               </a:rPr>
               <a:t>세운 (올해)</a:t>
             </a:r>
@@ -12896,9 +12896,9 @@
                 <a:solidFill>
                   <a:srgbClr val="0C0A09"/>
                 </a:solidFill>
-                <a:latin typeface="paybooc OTF" pitchFamily="34" charset="0"/>
-                <a:ea typeface="paybooc OTF" pitchFamily="34" charset="-122"/>
-                <a:cs typeface="paybooc OTF" pitchFamily="34" charset="-120"/>
+                <a:latin typeface="Pretendard Light" pitchFamily="34" charset="0"/>
+                <a:ea typeface="Pretendard Light" pitchFamily="34" charset="-122"/>
+                <a:cs typeface="Pretendard Light" pitchFamily="34" charset="-120"/>
               </a:rPr>
               <a:t>수수 사주교육</a:t>
             </a:r>
@@ -12934,9 +12934,9 @@
                 <a:solidFill>
                   <a:srgbClr val="777169"/>
                 </a:solidFill>
-                <a:latin typeface="paybooc OTF" pitchFamily="34" charset="0"/>
-                <a:ea typeface="paybooc OTF" pitchFamily="34" charset="-122"/>
-                <a:cs typeface="paybooc OTF" pitchFamily="34" charset="-120"/>
+                <a:latin typeface="Pretendard Light" pitchFamily="34" charset="0"/>
+                <a:ea typeface="Pretendard Light" pitchFamily="34" charset="-122"/>
+                <a:cs typeface="Pretendard Light" pitchFamily="34" charset="-120"/>
               </a:rPr>
               <a:t>04</a:t>
             </a:r>
@@ -12972,9 +12972,9 @@
                 <a:solidFill>
                   <a:srgbClr val="777169"/>
                 </a:solidFill>
-                <a:latin typeface="paybooc OTF" pitchFamily="34" charset="0"/>
-                <a:ea typeface="paybooc OTF" pitchFamily="34" charset="-122"/>
-                <a:cs typeface="paybooc OTF" pitchFamily="34" charset="-120"/>
+                <a:latin typeface="Pretendard Light" pitchFamily="34" charset="0"/>
+                <a:ea typeface="Pretendard Light" pitchFamily="34" charset="-122"/>
+                <a:cs typeface="Pretendard Light" pitchFamily="34" charset="-120"/>
               </a:rPr>
               <a:t>04 · 만세력으로 직접 읽기</a:t>
             </a:r>
@@ -13048,9 +13048,9 @@
                 <a:solidFill>
                   <a:srgbClr val="777169"/>
                 </a:solidFill>
-                <a:latin typeface="paybooc OTF" pitchFamily="34" charset="0"/>
-                <a:ea typeface="paybooc OTF" pitchFamily="34" charset="-122"/>
-                <a:cs typeface="paybooc OTF" pitchFamily="34" charset="-120"/>
+                <a:latin typeface="Pretendard Light" pitchFamily="34" charset="0"/>
+                <a:ea typeface="Pretendard Light" pitchFamily="34" charset="-122"/>
+                <a:cs typeface="Pretendard Light" pitchFamily="34" charset="-120"/>
               </a:rPr>
               <a:t>내 대운이 몇 살에 바뀌는지</a:t>
             </a:r>
@@ -13180,9 +13180,9 @@
                 <a:solidFill>
                   <a:srgbClr val="0C0A09"/>
                 </a:solidFill>
-                <a:latin typeface="paybooc OTF" pitchFamily="34" charset="0"/>
-                <a:ea typeface="paybooc OTF" pitchFamily="34" charset="-122"/>
-                <a:cs typeface="paybooc OTF" pitchFamily="34" charset="-120"/>
+                <a:latin typeface="Pretendard Light" pitchFamily="34" charset="0"/>
+                <a:ea typeface="Pretendard Light" pitchFamily="34" charset="-122"/>
+                <a:cs typeface="Pretendard Light" pitchFamily="34" charset="-120"/>
               </a:rPr>
               <a:t>대운수를 확인한다</a:t>
             </a:r>
@@ -13353,9 +13353,9 @@
                 <a:solidFill>
                   <a:srgbClr val="0C0A09"/>
                 </a:solidFill>
-                <a:latin typeface="paybooc OTF" pitchFamily="34" charset="0"/>
-                <a:ea typeface="paybooc OTF" pitchFamily="34" charset="-122"/>
-                <a:cs typeface="paybooc OTF" pitchFamily="34" charset="-120"/>
+                <a:latin typeface="Pretendard Light" pitchFamily="34" charset="0"/>
+                <a:ea typeface="Pretendard Light" pitchFamily="34" charset="-122"/>
+                <a:cs typeface="Pretendard Light" pitchFamily="34" charset="-120"/>
               </a:rPr>
               <a:t>지금 내 대운 칸을 찾는다</a:t>
             </a:r>
@@ -13526,9 +13526,9 @@
                 <a:solidFill>
                   <a:srgbClr val="0C0A09"/>
                 </a:solidFill>
-                <a:latin typeface="paybooc OTF" pitchFamily="34" charset="0"/>
-                <a:ea typeface="paybooc OTF" pitchFamily="34" charset="-122"/>
-                <a:cs typeface="paybooc OTF" pitchFamily="34" charset="-120"/>
+                <a:latin typeface="Pretendard Light" pitchFamily="34" charset="0"/>
+                <a:ea typeface="Pretendard Light" pitchFamily="34" charset="-122"/>
+                <a:cs typeface="Pretendard Light" pitchFamily="34" charset="-120"/>
               </a:rPr>
               <a:t>그 간지의 오행을 본다</a:t>
             </a:r>
@@ -13759,9 +13759,9 @@
                 <a:solidFill>
                   <a:srgbClr val="0C0A09"/>
                 </a:solidFill>
-                <a:latin typeface="paybooc OTF" pitchFamily="34" charset="0"/>
-                <a:ea typeface="paybooc OTF" pitchFamily="34" charset="-122"/>
-                <a:cs typeface="paybooc OTF" pitchFamily="34" charset="-120"/>
+                <a:latin typeface="Pretendard Light" pitchFamily="34" charset="0"/>
+                <a:ea typeface="Pretendard Light" pitchFamily="34" charset="-122"/>
+                <a:cs typeface="Pretendard Light" pitchFamily="34" charset="-120"/>
               </a:rPr>
               <a:t>수수 사주교육</a:t>
             </a:r>
@@ -13797,9 +13797,9 @@
                 <a:solidFill>
                   <a:srgbClr val="777169"/>
                 </a:solidFill>
-                <a:latin typeface="paybooc OTF" pitchFamily="34" charset="0"/>
-                <a:ea typeface="paybooc OTF" pitchFamily="34" charset="-122"/>
-                <a:cs typeface="paybooc OTF" pitchFamily="34" charset="-120"/>
+                <a:latin typeface="Pretendard Light" pitchFamily="34" charset="0"/>
+                <a:ea typeface="Pretendard Light" pitchFamily="34" charset="-122"/>
+                <a:cs typeface="Pretendard Light" pitchFamily="34" charset="-120"/>
               </a:rPr>
               <a:t>04</a:t>
             </a:r>
@@ -13835,9 +13835,9 @@
                 <a:solidFill>
                   <a:srgbClr val="777169"/>
                 </a:solidFill>
-                <a:latin typeface="paybooc OTF" pitchFamily="34" charset="0"/>
-                <a:ea typeface="paybooc OTF" pitchFamily="34" charset="-122"/>
-                <a:cs typeface="paybooc OTF" pitchFamily="34" charset="-120"/>
+                <a:latin typeface="Pretendard Light" pitchFamily="34" charset="0"/>
+                <a:ea typeface="Pretendard Light" pitchFamily="34" charset="-122"/>
+                <a:cs typeface="Pretendard Light" pitchFamily="34" charset="-120"/>
               </a:rPr>
               <a:t>04 · 만세력으로 직접 읽기</a:t>
             </a:r>
@@ -13911,9 +13911,9 @@
                 <a:solidFill>
                   <a:srgbClr val="777169"/>
                 </a:solidFill>
-                <a:latin typeface="paybooc OTF" pitchFamily="34" charset="0"/>
-                <a:ea typeface="paybooc OTF" pitchFamily="34" charset="-122"/>
-                <a:cs typeface="paybooc OTF" pitchFamily="34" charset="-120"/>
+                <a:latin typeface="Pretendard Light" pitchFamily="34" charset="0"/>
+                <a:ea typeface="Pretendard Light" pitchFamily="34" charset="-122"/>
+                <a:cs typeface="Pretendard Light" pitchFamily="34" charset="-120"/>
               </a:rPr>
               <a:t>올해가 나에게 어떤 해인지</a:t>
             </a:r>
@@ -14043,9 +14043,9 @@
                 <a:solidFill>
                   <a:srgbClr val="0C0A09"/>
                 </a:solidFill>
-                <a:latin typeface="paybooc OTF" pitchFamily="34" charset="0"/>
-                <a:ea typeface="paybooc OTF" pitchFamily="34" charset="-122"/>
-                <a:cs typeface="paybooc OTF" pitchFamily="34" charset="-120"/>
+                <a:latin typeface="Pretendard Light" pitchFamily="34" charset="0"/>
+                <a:ea typeface="Pretendard Light" pitchFamily="34" charset="-122"/>
+                <a:cs typeface="Pretendard Light" pitchFamily="34" charset="-120"/>
               </a:rPr>
               <a:t>올해 간지를 확인한다</a:t>
             </a:r>
@@ -14216,9 +14216,9 @@
                 <a:solidFill>
                   <a:srgbClr val="0C0A09"/>
                 </a:solidFill>
-                <a:latin typeface="paybooc OTF" pitchFamily="34" charset="0"/>
-                <a:ea typeface="paybooc OTF" pitchFamily="34" charset="-122"/>
-                <a:cs typeface="paybooc OTF" pitchFamily="34" charset="-120"/>
+                <a:latin typeface="Pretendard Light" pitchFamily="34" charset="0"/>
+                <a:ea typeface="Pretendard Light" pitchFamily="34" charset="-122"/>
+                <a:cs typeface="Pretendard Light" pitchFamily="34" charset="-120"/>
               </a:rPr>
               <a:t>오행 성분을 본다</a:t>
             </a:r>
@@ -14389,9 +14389,9 @@
                 <a:solidFill>
                   <a:srgbClr val="0C0A09"/>
                 </a:solidFill>
-                <a:latin typeface="paybooc OTF" pitchFamily="34" charset="0"/>
-                <a:ea typeface="paybooc OTF" pitchFamily="34" charset="-122"/>
-                <a:cs typeface="paybooc OTF" pitchFamily="34" charset="-120"/>
+                <a:latin typeface="Pretendard Light" pitchFamily="34" charset="0"/>
+                <a:ea typeface="Pretendard Light" pitchFamily="34" charset="-122"/>
+                <a:cs typeface="Pretendard Light" pitchFamily="34" charset="-120"/>
               </a:rPr>
               <a:t>내 원국·대운과 대입한다</a:t>
             </a:r>
@@ -14622,9 +14622,9 @@
                 <a:solidFill>
                   <a:srgbClr val="0C0A09"/>
                 </a:solidFill>
-                <a:latin typeface="paybooc OTF" pitchFamily="34" charset="0"/>
-                <a:ea typeface="paybooc OTF" pitchFamily="34" charset="-122"/>
-                <a:cs typeface="paybooc OTF" pitchFamily="34" charset="-120"/>
+                <a:latin typeface="Pretendard Light" pitchFamily="34" charset="0"/>
+                <a:ea typeface="Pretendard Light" pitchFamily="34" charset="-122"/>
+                <a:cs typeface="Pretendard Light" pitchFamily="34" charset="-120"/>
               </a:rPr>
               <a:t>수수 사주교육</a:t>
             </a:r>
@@ -14660,9 +14660,9 @@
                 <a:solidFill>
                   <a:srgbClr val="777169"/>
                 </a:solidFill>
-                <a:latin typeface="paybooc OTF" pitchFamily="34" charset="0"/>
-                <a:ea typeface="paybooc OTF" pitchFamily="34" charset="-122"/>
-                <a:cs typeface="paybooc OTF" pitchFamily="34" charset="-120"/>
+                <a:latin typeface="Pretendard Light" pitchFamily="34" charset="0"/>
+                <a:ea typeface="Pretendard Light" pitchFamily="34" charset="-122"/>
+                <a:cs typeface="Pretendard Light" pitchFamily="34" charset="-120"/>
               </a:rPr>
               <a:t>04</a:t>
             </a:r>
@@ -14698,9 +14698,9 @@
                 <a:solidFill>
                   <a:srgbClr val="777169"/>
                 </a:solidFill>
-                <a:latin typeface="paybooc OTF" pitchFamily="34" charset="0"/>
-                <a:ea typeface="paybooc OTF" pitchFamily="34" charset="-122"/>
-                <a:cs typeface="paybooc OTF" pitchFamily="34" charset="-120"/>
+                <a:latin typeface="Pretendard Light" pitchFamily="34" charset="0"/>
+                <a:ea typeface="Pretendard Light" pitchFamily="34" charset="-122"/>
+                <a:cs typeface="Pretendard Light" pitchFamily="34" charset="-120"/>
               </a:rPr>
               <a:t>04 · 만세력으로 직접 읽기</a:t>
             </a:r>
@@ -14774,9 +14774,9 @@
                 <a:solidFill>
                   <a:srgbClr val="777169"/>
                 </a:solidFill>
-                <a:latin typeface="paybooc OTF" pitchFamily="34" charset="0"/>
-                <a:ea typeface="paybooc OTF" pitchFamily="34" charset="-122"/>
-                <a:cs typeface="paybooc OTF" pitchFamily="34" charset="-120"/>
+                <a:latin typeface="Pretendard Light" pitchFamily="34" charset="0"/>
+                <a:ea typeface="Pretendard Light" pitchFamily="34" charset="-122"/>
+                <a:cs typeface="Pretendard Light" pitchFamily="34" charset="-120"/>
               </a:rPr>
               <a:t>겨울에 태어난 庚金의 사례</a:t>
             </a:r>
@@ -14846,9 +14846,9 @@
                 <a:solidFill>
                   <a:srgbClr val="777169"/>
                 </a:solidFill>
-                <a:latin typeface="paybooc OTF" pitchFamily="34" charset="0"/>
-                <a:ea typeface="paybooc OTF" pitchFamily="34" charset="-122"/>
-                <a:cs typeface="paybooc OTF" pitchFamily="34" charset="-120"/>
+                <a:latin typeface="Pretendard Light" pitchFamily="34" charset="0"/>
+                <a:ea typeface="Pretendard Light" pitchFamily="34" charset="-122"/>
+                <a:cs typeface="Pretendard Light" pitchFamily="34" charset="-120"/>
               </a:rPr>
               <a:t>예시 명식</a:t>
             </a:r>
@@ -14959,9 +14959,9 @@
                 <a:solidFill>
                   <a:srgbClr val="777169"/>
                 </a:solidFill>
-                <a:latin typeface="paybooc OTF" pitchFamily="34" charset="0"/>
-                <a:ea typeface="paybooc OTF" pitchFamily="34" charset="-122"/>
-                <a:cs typeface="paybooc OTF" pitchFamily="34" charset="-120"/>
+                <a:latin typeface="Pretendard Light" pitchFamily="34" charset="0"/>
+                <a:ea typeface="Pretendard Light" pitchFamily="34" charset="-122"/>
+                <a:cs typeface="Pretendard Light" pitchFamily="34" charset="-120"/>
               </a:rPr>
               <a:t>원국</a:t>
             </a:r>
@@ -14997,9 +14997,9 @@
                 <a:solidFill>
                   <a:srgbClr val="0C0A09"/>
                 </a:solidFill>
-                <a:latin typeface="paybooc OTF" pitchFamily="34" charset="0"/>
-                <a:ea typeface="paybooc OTF" pitchFamily="34" charset="-122"/>
-                <a:cs typeface="paybooc OTF" pitchFamily="34" charset="-120"/>
+                <a:latin typeface="Pretendard Light" pitchFamily="34" charset="0"/>
+                <a:ea typeface="Pretendard Light" pitchFamily="34" charset="-122"/>
+                <a:cs typeface="Pretendard Light" pitchFamily="34" charset="-120"/>
               </a:rPr>
               <a:t>타고난 나</a:t>
             </a:r>
@@ -15110,9 +15110,9 @@
                 <a:solidFill>
                   <a:srgbClr val="777169"/>
                 </a:solidFill>
-                <a:latin typeface="paybooc OTF" pitchFamily="34" charset="0"/>
-                <a:ea typeface="paybooc OTF" pitchFamily="34" charset="-122"/>
-                <a:cs typeface="paybooc OTF" pitchFamily="34" charset="-120"/>
+                <a:latin typeface="Pretendard Light" pitchFamily="34" charset="0"/>
+                <a:ea typeface="Pretendard Light" pitchFamily="34" charset="-122"/>
+                <a:cs typeface="Pretendard Light" pitchFamily="34" charset="-120"/>
               </a:rPr>
               <a:t>대운</a:t>
             </a:r>
@@ -15148,9 +15148,9 @@
                 <a:solidFill>
                   <a:srgbClr val="0C0A09"/>
                 </a:solidFill>
-                <a:latin typeface="paybooc OTF" pitchFamily="34" charset="0"/>
-                <a:ea typeface="paybooc OTF" pitchFamily="34" charset="-122"/>
-                <a:cs typeface="paybooc OTF" pitchFamily="34" charset="-120"/>
+                <a:latin typeface="Pretendard Light" pitchFamily="34" charset="0"/>
+                <a:ea typeface="Pretendard Light" pitchFamily="34" charset="-122"/>
+                <a:cs typeface="Pretendard Light" pitchFamily="34" charset="-120"/>
               </a:rPr>
               <a:t>지금 대운</a:t>
             </a:r>
@@ -15261,9 +15261,9 @@
                 <a:solidFill>
                   <a:srgbClr val="777169"/>
                 </a:solidFill>
-                <a:latin typeface="paybooc OTF" pitchFamily="34" charset="0"/>
-                <a:ea typeface="paybooc OTF" pitchFamily="34" charset="-122"/>
-                <a:cs typeface="paybooc OTF" pitchFamily="34" charset="-120"/>
+                <a:latin typeface="Pretendard Light" pitchFamily="34" charset="0"/>
+                <a:ea typeface="Pretendard Light" pitchFamily="34" charset="-122"/>
+                <a:cs typeface="Pretendard Light" pitchFamily="34" charset="-120"/>
               </a:rPr>
               <a:t>세운</a:t>
             </a:r>
@@ -15299,9 +15299,9 @@
                 <a:solidFill>
                   <a:srgbClr val="0C0A09"/>
                 </a:solidFill>
-                <a:latin typeface="paybooc OTF" pitchFamily="34" charset="0"/>
-                <a:ea typeface="paybooc OTF" pitchFamily="34" charset="-122"/>
-                <a:cs typeface="paybooc OTF" pitchFamily="34" charset="-120"/>
+                <a:latin typeface="Pretendard Light" pitchFamily="34" charset="0"/>
+                <a:ea typeface="Pretendard Light" pitchFamily="34" charset="-122"/>
+                <a:cs typeface="Pretendard Light" pitchFamily="34" charset="-120"/>
               </a:rPr>
               <a:t>올해 세운</a:t>
             </a:r>
@@ -15614,9 +15614,9 @@
                 <a:solidFill>
                   <a:srgbClr val="0C0A09"/>
                 </a:solidFill>
-                <a:latin typeface="paybooc OTF" pitchFamily="34" charset="0"/>
-                <a:ea typeface="paybooc OTF" pitchFamily="34" charset="-122"/>
-                <a:cs typeface="paybooc OTF" pitchFamily="34" charset="-120"/>
+                <a:latin typeface="Pretendard Light" pitchFamily="34" charset="0"/>
+                <a:ea typeface="Pretendard Light" pitchFamily="34" charset="-122"/>
+                <a:cs typeface="Pretendard Light" pitchFamily="34" charset="-120"/>
               </a:rPr>
               <a:t>수수 사주교육</a:t>
             </a:r>
@@ -15652,9 +15652,9 @@
                 <a:solidFill>
                   <a:srgbClr val="777169"/>
                 </a:solidFill>
-                <a:latin typeface="paybooc OTF" pitchFamily="34" charset="0"/>
-                <a:ea typeface="paybooc OTF" pitchFamily="34" charset="-122"/>
-                <a:cs typeface="paybooc OTF" pitchFamily="34" charset="-120"/>
+                <a:latin typeface="Pretendard Light" pitchFamily="34" charset="0"/>
+                <a:ea typeface="Pretendard Light" pitchFamily="34" charset="-122"/>
+                <a:cs typeface="Pretendard Light" pitchFamily="34" charset="-120"/>
               </a:rPr>
               <a:t>SECTION 05</a:t>
             </a:r>
@@ -15690,9 +15690,9 @@
                 <a:solidFill>
                   <a:srgbClr val="777169"/>
                 </a:solidFill>
-                <a:latin typeface="paybooc OTF" pitchFamily="34" charset="0"/>
-                <a:ea typeface="paybooc OTF" pitchFamily="34" charset="-122"/>
-                <a:cs typeface="paybooc OTF" pitchFamily="34" charset="-120"/>
+                <a:latin typeface="Pretendard Light" pitchFamily="34" charset="0"/>
+                <a:ea typeface="Pretendard Light" pitchFamily="34" charset="-122"/>
+                <a:cs typeface="Pretendard Light" pitchFamily="34" charset="-120"/>
               </a:rPr>
               <a:t>SECTION 05</a:t>
             </a:r>
@@ -15766,9 +15766,9 @@
                 <a:solidFill>
                   <a:srgbClr val="A8A29E"/>
                 </a:solidFill>
-                <a:latin typeface="paybooc OTF" pitchFamily="34" charset="0"/>
-                <a:ea typeface="paybooc OTF" pitchFamily="34" charset="-122"/>
-                <a:cs typeface="paybooc OTF" pitchFamily="34" charset="-120"/>
+                <a:latin typeface="Pretendard Light" pitchFamily="34" charset="0"/>
+                <a:ea typeface="Pretendard Light" pitchFamily="34" charset="-122"/>
+                <a:cs typeface="Pretendard Light" pitchFamily="34" charset="-120"/>
               </a:rPr>
               <a:t>HOW LUCK MEETS THE CHART · 생극제화</a:t>
             </a:r>
@@ -15999,9 +15999,9 @@
                 <a:solidFill>
                   <a:srgbClr val="0C0A09"/>
                 </a:solidFill>
-                <a:latin typeface="paybooc OTF" pitchFamily="34" charset="0"/>
-                <a:ea typeface="paybooc OTF" pitchFamily="34" charset="-122"/>
-                <a:cs typeface="paybooc OTF" pitchFamily="34" charset="-120"/>
+                <a:latin typeface="Pretendard Light" pitchFamily="34" charset="0"/>
+                <a:ea typeface="Pretendard Light" pitchFamily="34" charset="-122"/>
+                <a:cs typeface="Pretendard Light" pitchFamily="34" charset="-120"/>
               </a:rPr>
               <a:t>수수 사주교육</a:t>
             </a:r>
@@ -16037,9 +16037,9 @@
                 <a:solidFill>
                   <a:srgbClr val="777169"/>
                 </a:solidFill>
-                <a:latin typeface="paybooc OTF" pitchFamily="34" charset="0"/>
-                <a:ea typeface="paybooc OTF" pitchFamily="34" charset="-122"/>
-                <a:cs typeface="paybooc OTF" pitchFamily="34" charset="-120"/>
+                <a:latin typeface="Pretendard Light" pitchFamily="34" charset="0"/>
+                <a:ea typeface="Pretendard Light" pitchFamily="34" charset="-122"/>
+                <a:cs typeface="Pretendard Light" pitchFamily="34" charset="-120"/>
               </a:rPr>
               <a:t>05</a:t>
             </a:r>
@@ -16075,9 +16075,9 @@
                 <a:solidFill>
                   <a:srgbClr val="777169"/>
                 </a:solidFill>
-                <a:latin typeface="paybooc OTF" pitchFamily="34" charset="0"/>
-                <a:ea typeface="paybooc OTF" pitchFamily="34" charset="-122"/>
-                <a:cs typeface="paybooc OTF" pitchFamily="34" charset="-120"/>
+                <a:latin typeface="Pretendard Light" pitchFamily="34" charset="0"/>
+                <a:ea typeface="Pretendard Light" pitchFamily="34" charset="-122"/>
+                <a:cs typeface="Pretendard Light" pitchFamily="34" charset="-120"/>
               </a:rPr>
               <a:t>05 · 운 해석의 기초</a:t>
             </a:r>
@@ -16151,9 +16151,9 @@
                 <a:solidFill>
                   <a:srgbClr val="777169"/>
                 </a:solidFill>
-                <a:latin typeface="paybooc OTF" pitchFamily="34" charset="0"/>
-                <a:ea typeface="paybooc OTF" pitchFamily="34" charset="-122"/>
-                <a:cs typeface="paybooc OTF" pitchFamily="34" charset="-120"/>
+                <a:latin typeface="Pretendard Light" pitchFamily="34" charset="0"/>
+                <a:ea typeface="Pretendard Light" pitchFamily="34" charset="-122"/>
+                <a:cs typeface="Pretendard Light" pitchFamily="34" charset="-120"/>
               </a:rPr>
               <a:t>오행이 서로 돕고 누르는 관계</a:t>
             </a:r>
@@ -16245,9 +16245,9 @@
                 <a:solidFill>
                   <a:srgbClr val="777169"/>
                 </a:solidFill>
-                <a:latin typeface="paybooc OTF" pitchFamily="34" charset="0"/>
-                <a:ea typeface="paybooc OTF" pitchFamily="34" charset="-122"/>
-                <a:cs typeface="paybooc OTF" pitchFamily="34" charset="-120"/>
+                <a:latin typeface="Pretendard Light" pitchFamily="34" charset="0"/>
+                <a:ea typeface="Pretendard Light" pitchFamily="34" charset="-122"/>
+                <a:cs typeface="Pretendard Light" pitchFamily="34" charset="-120"/>
               </a:rPr>
               <a:t>相生 · 상생</a:t>
             </a:r>
@@ -16283,9 +16283,9 @@
                 <a:solidFill>
                   <a:srgbClr val="0C0A09"/>
                 </a:solidFill>
-                <a:latin typeface="paybooc OTF" pitchFamily="34" charset="0"/>
-                <a:ea typeface="paybooc OTF" pitchFamily="34" charset="-122"/>
-                <a:cs typeface="paybooc OTF" pitchFamily="34" charset="-120"/>
+                <a:latin typeface="Pretendard Light" pitchFamily="34" charset="0"/>
+                <a:ea typeface="Pretendard Light" pitchFamily="34" charset="-122"/>
+                <a:cs typeface="Pretendard Light" pitchFamily="34" charset="-120"/>
               </a:rPr>
               <a:t>낳고 돕는다</a:t>
             </a:r>
@@ -16479,9 +16479,9 @@
                 <a:solidFill>
                   <a:srgbClr val="777169"/>
                 </a:solidFill>
-                <a:latin typeface="paybooc OTF" pitchFamily="34" charset="0"/>
-                <a:ea typeface="paybooc OTF" pitchFamily="34" charset="-122"/>
-                <a:cs typeface="paybooc OTF" pitchFamily="34" charset="-120"/>
+                <a:latin typeface="Pretendard Light" pitchFamily="34" charset="0"/>
+                <a:ea typeface="Pretendard Light" pitchFamily="34" charset="-122"/>
+                <a:cs typeface="Pretendard Light" pitchFamily="34" charset="-120"/>
               </a:rPr>
               <a:t>相剋 · 상극</a:t>
             </a:r>
@@ -16517,9 +16517,9 @@
                 <a:solidFill>
                   <a:srgbClr val="0C0A09"/>
                 </a:solidFill>
-                <a:latin typeface="paybooc OTF" pitchFamily="34" charset="0"/>
-                <a:ea typeface="paybooc OTF" pitchFamily="34" charset="-122"/>
-                <a:cs typeface="paybooc OTF" pitchFamily="34" charset="-120"/>
+                <a:latin typeface="Pretendard Light" pitchFamily="34" charset="0"/>
+                <a:ea typeface="Pretendard Light" pitchFamily="34" charset="-122"/>
+                <a:cs typeface="Pretendard Light" pitchFamily="34" charset="-120"/>
               </a:rPr>
               <a:t>누르고 통제</a:t>
             </a:r>
@@ -16691,9 +16691,9 @@
                 <a:solidFill>
                   <a:srgbClr val="777169"/>
                 </a:solidFill>
-                <a:latin typeface="paybooc OTF" pitchFamily="34" charset="0"/>
-                <a:ea typeface="paybooc OTF" pitchFamily="34" charset="-122"/>
-                <a:cs typeface="paybooc OTF" pitchFamily="34" charset="-120"/>
+                <a:latin typeface="Pretendard Light" pitchFamily="34" charset="0"/>
+                <a:ea typeface="Pretendard Light" pitchFamily="34" charset="-122"/>
+                <a:cs typeface="Pretendard Light" pitchFamily="34" charset="-120"/>
               </a:rPr>
               <a:t>운 해석</a:t>
             </a:r>
@@ -16924,9 +16924,9 @@
                 <a:solidFill>
                   <a:srgbClr val="0C0A09"/>
                 </a:solidFill>
-                <a:latin typeface="paybooc OTF" pitchFamily="34" charset="0"/>
-                <a:ea typeface="paybooc OTF" pitchFamily="34" charset="-122"/>
-                <a:cs typeface="paybooc OTF" pitchFamily="34" charset="-120"/>
+                <a:latin typeface="Pretendard Light" pitchFamily="34" charset="0"/>
+                <a:ea typeface="Pretendard Light" pitchFamily="34" charset="-122"/>
+                <a:cs typeface="Pretendard Light" pitchFamily="34" charset="-120"/>
               </a:rPr>
               <a:t>수수 사주교육</a:t>
             </a:r>
@@ -16962,9 +16962,9 @@
                 <a:solidFill>
                   <a:srgbClr val="777169"/>
                 </a:solidFill>
-                <a:latin typeface="paybooc OTF" pitchFamily="34" charset="0"/>
-                <a:ea typeface="paybooc OTF" pitchFamily="34" charset="-122"/>
-                <a:cs typeface="paybooc OTF" pitchFamily="34" charset="-120"/>
+                <a:latin typeface="Pretendard Light" pitchFamily="34" charset="0"/>
+                <a:ea typeface="Pretendard Light" pitchFamily="34" charset="-122"/>
+                <a:cs typeface="Pretendard Light" pitchFamily="34" charset="-120"/>
               </a:rPr>
               <a:t>05</a:t>
             </a:r>
@@ -17000,9 +17000,9 @@
                 <a:solidFill>
                   <a:srgbClr val="777169"/>
                 </a:solidFill>
-                <a:latin typeface="paybooc OTF" pitchFamily="34" charset="0"/>
-                <a:ea typeface="paybooc OTF" pitchFamily="34" charset="-122"/>
-                <a:cs typeface="paybooc OTF" pitchFamily="34" charset="-120"/>
+                <a:latin typeface="Pretendard Light" pitchFamily="34" charset="0"/>
+                <a:ea typeface="Pretendard Light" pitchFamily="34" charset="-122"/>
+                <a:cs typeface="Pretendard Light" pitchFamily="34" charset="-120"/>
               </a:rPr>
               <a:t>05 · 운 해석의 기초</a:t>
             </a:r>
@@ -17076,9 +17076,9 @@
                 <a:solidFill>
                   <a:srgbClr val="777169"/>
                 </a:solidFill>
-                <a:latin typeface="paybooc OTF" pitchFamily="34" charset="0"/>
-                <a:ea typeface="paybooc OTF" pitchFamily="34" charset="-122"/>
-                <a:cs typeface="paybooc OTF" pitchFamily="34" charset="-120"/>
+                <a:latin typeface="Pretendard Light" pitchFamily="34" charset="0"/>
+                <a:ea typeface="Pretendard Light" pitchFamily="34" charset="-122"/>
+                <a:cs typeface="Pretendard Light" pitchFamily="34" charset="-120"/>
               </a:rPr>
               <a:t>용신(用神)을 만나는 상승기</a:t>
             </a:r>
@@ -17148,9 +17148,9 @@
                 <a:solidFill>
                   <a:srgbClr val="777169"/>
                 </a:solidFill>
-                <a:latin typeface="paybooc OTF" pitchFamily="34" charset="0"/>
-                <a:ea typeface="paybooc OTF" pitchFamily="34" charset="-122"/>
-                <a:cs typeface="paybooc OTF" pitchFamily="34" charset="-120"/>
+                <a:latin typeface="Pretendard Light" pitchFamily="34" charset="0"/>
+                <a:ea typeface="Pretendard Light" pitchFamily="34" charset="-122"/>
+                <a:cs typeface="Pretendard Light" pitchFamily="34" charset="-120"/>
               </a:rPr>
               <a:t>원국</a:t>
             </a:r>
@@ -17265,9 +17265,9 @@
                 <a:solidFill>
                   <a:srgbClr val="A8A29E"/>
                 </a:solidFill>
-                <a:latin typeface="paybooc OTF" pitchFamily="34" charset="0"/>
-                <a:ea typeface="paybooc OTF" pitchFamily="34" charset="-122"/>
-                <a:cs typeface="paybooc OTF" pitchFamily="34" charset="-120"/>
+                <a:latin typeface="Pretendard Light" pitchFamily="34" charset="0"/>
+                <a:ea typeface="Pretendard Light" pitchFamily="34" charset="-122"/>
+                <a:cs typeface="Pretendard Light" pitchFamily="34" charset="-120"/>
               </a:rPr>
               <a:t>→</a:t>
             </a:r>
@@ -17337,9 +17337,9 @@
                 <a:solidFill>
                   <a:srgbClr val="777169"/>
                 </a:solidFill>
-                <a:latin typeface="paybooc OTF" pitchFamily="34" charset="0"/>
-                <a:ea typeface="paybooc OTF" pitchFamily="34" charset="-122"/>
-                <a:cs typeface="paybooc OTF" pitchFamily="34" charset="-120"/>
+                <a:latin typeface="Pretendard Light" pitchFamily="34" charset="0"/>
+                <a:ea typeface="Pretendard Light" pitchFamily="34" charset="-122"/>
+                <a:cs typeface="Pretendard Light" pitchFamily="34" charset="-120"/>
               </a:rPr>
               <a:t>운</a:t>
             </a:r>
@@ -17473,9 +17473,9 @@
                 <a:solidFill>
                   <a:srgbClr val="A8A29E"/>
                 </a:solidFill>
-                <a:latin typeface="paybooc OTF" pitchFamily="34" charset="0"/>
-                <a:ea typeface="paybooc OTF" pitchFamily="34" charset="-122"/>
-                <a:cs typeface="paybooc OTF" pitchFamily="34" charset="-120"/>
+                <a:latin typeface="Pretendard Light" pitchFamily="34" charset="0"/>
+                <a:ea typeface="Pretendard Light" pitchFamily="34" charset="-122"/>
+                <a:cs typeface="Pretendard Light" pitchFamily="34" charset="-120"/>
               </a:rPr>
               <a:t>→</a:t>
             </a:r>
@@ -17545,9 +17545,9 @@
                 <a:solidFill>
                   <a:srgbClr val="777169"/>
                 </a:solidFill>
-                <a:latin typeface="paybooc OTF" pitchFamily="34" charset="0"/>
-                <a:ea typeface="paybooc OTF" pitchFamily="34" charset="-122"/>
-                <a:cs typeface="paybooc OTF" pitchFamily="34" charset="-120"/>
+                <a:latin typeface="Pretendard Light" pitchFamily="34" charset="0"/>
+                <a:ea typeface="Pretendard Light" pitchFamily="34" charset="-122"/>
+                <a:cs typeface="Pretendard Light" pitchFamily="34" charset="-120"/>
               </a:rPr>
               <a:t>결과</a:t>
             </a:r>
@@ -17696,9 +17696,9 @@
                 <a:solidFill>
                   <a:srgbClr val="777169"/>
                 </a:solidFill>
-                <a:latin typeface="paybooc OTF" pitchFamily="34" charset="0"/>
-                <a:ea typeface="paybooc OTF" pitchFamily="34" charset="-122"/>
-                <a:cs typeface="paybooc OTF" pitchFamily="34" charset="-120"/>
+                <a:latin typeface="Pretendard Light" pitchFamily="34" charset="0"/>
+                <a:ea typeface="Pretendard Light" pitchFamily="34" charset="-122"/>
+                <a:cs typeface="Pretendard Light" pitchFamily="34" charset="-120"/>
               </a:rPr>
               <a:t>용신</a:t>
             </a:r>
@@ -17967,9 +17967,9 @@
                 <a:solidFill>
                   <a:srgbClr val="0C0A09"/>
                 </a:solidFill>
-                <a:latin typeface="paybooc OTF" pitchFamily="34" charset="0"/>
-                <a:ea typeface="paybooc OTF" pitchFamily="34" charset="-122"/>
-                <a:cs typeface="paybooc OTF" pitchFamily="34" charset="-120"/>
+                <a:latin typeface="Pretendard Light" pitchFamily="34" charset="0"/>
+                <a:ea typeface="Pretendard Light" pitchFamily="34" charset="-122"/>
+                <a:cs typeface="Pretendard Light" pitchFamily="34" charset="-120"/>
               </a:rPr>
               <a:t>수수 사주교육</a:t>
             </a:r>
@@ -18005,9 +18005,9 @@
                 <a:solidFill>
                   <a:srgbClr val="777169"/>
                 </a:solidFill>
-                <a:latin typeface="paybooc OTF" pitchFamily="34" charset="0"/>
-                <a:ea typeface="paybooc OTF" pitchFamily="34" charset="-122"/>
-                <a:cs typeface="paybooc OTF" pitchFamily="34" charset="-120"/>
+                <a:latin typeface="Pretendard Light" pitchFamily="34" charset="0"/>
+                <a:ea typeface="Pretendard Light" pitchFamily="34" charset="-122"/>
+                <a:cs typeface="Pretendard Light" pitchFamily="34" charset="-120"/>
               </a:rPr>
               <a:t>05</a:t>
             </a:r>
@@ -18043,9 +18043,9 @@
                 <a:solidFill>
                   <a:srgbClr val="777169"/>
                 </a:solidFill>
-                <a:latin typeface="paybooc OTF" pitchFamily="34" charset="0"/>
-                <a:ea typeface="paybooc OTF" pitchFamily="34" charset="-122"/>
-                <a:cs typeface="paybooc OTF" pitchFamily="34" charset="-120"/>
+                <a:latin typeface="Pretendard Light" pitchFamily="34" charset="0"/>
+                <a:ea typeface="Pretendard Light" pitchFamily="34" charset="-122"/>
+                <a:cs typeface="Pretendard Light" pitchFamily="34" charset="-120"/>
               </a:rPr>
               <a:t>05 · 운 해석의 기초</a:t>
             </a:r>
@@ -18119,9 +18119,9 @@
                 <a:solidFill>
                   <a:srgbClr val="777169"/>
                 </a:solidFill>
-                <a:latin typeface="paybooc OTF" pitchFamily="34" charset="0"/>
-                <a:ea typeface="paybooc OTF" pitchFamily="34" charset="-122"/>
-                <a:cs typeface="paybooc OTF" pitchFamily="34" charset="-120"/>
+                <a:latin typeface="Pretendard Light" pitchFamily="34" charset="0"/>
+                <a:ea typeface="Pretendard Light" pitchFamily="34" charset="-122"/>
+                <a:cs typeface="Pretendard Light" pitchFamily="34" charset="-120"/>
               </a:rPr>
               <a:t>기신(忌神) 시기 — 조심 구간</a:t>
             </a:r>
@@ -18191,9 +18191,9 @@
                 <a:solidFill>
                   <a:srgbClr val="777169"/>
                 </a:solidFill>
-                <a:latin typeface="paybooc OTF" pitchFamily="34" charset="0"/>
-                <a:ea typeface="paybooc OTF" pitchFamily="34" charset="-122"/>
-                <a:cs typeface="paybooc OTF" pitchFamily="34" charset="-120"/>
+                <a:latin typeface="Pretendard Light" pitchFamily="34" charset="0"/>
+                <a:ea typeface="Pretendard Light" pitchFamily="34" charset="-122"/>
+                <a:cs typeface="Pretendard Light" pitchFamily="34" charset="-120"/>
               </a:rPr>
               <a:t>원국</a:t>
             </a:r>
@@ -18308,9 +18308,9 @@
                 <a:solidFill>
                   <a:srgbClr val="A8A29E"/>
                 </a:solidFill>
-                <a:latin typeface="paybooc OTF" pitchFamily="34" charset="0"/>
-                <a:ea typeface="paybooc OTF" pitchFamily="34" charset="-122"/>
-                <a:cs typeface="paybooc OTF" pitchFamily="34" charset="-120"/>
+                <a:latin typeface="Pretendard Light" pitchFamily="34" charset="0"/>
+                <a:ea typeface="Pretendard Light" pitchFamily="34" charset="-122"/>
+                <a:cs typeface="Pretendard Light" pitchFamily="34" charset="-120"/>
               </a:rPr>
               <a:t>→</a:t>
             </a:r>
@@ -18380,9 +18380,9 @@
                 <a:solidFill>
                   <a:srgbClr val="777169"/>
                 </a:solidFill>
-                <a:latin typeface="paybooc OTF" pitchFamily="34" charset="0"/>
-                <a:ea typeface="paybooc OTF" pitchFamily="34" charset="-122"/>
-                <a:cs typeface="paybooc OTF" pitchFamily="34" charset="-120"/>
+                <a:latin typeface="Pretendard Light" pitchFamily="34" charset="0"/>
+                <a:ea typeface="Pretendard Light" pitchFamily="34" charset="-122"/>
+                <a:cs typeface="Pretendard Light" pitchFamily="34" charset="-120"/>
               </a:rPr>
               <a:t>운</a:t>
             </a:r>
@@ -18516,9 +18516,9 @@
                 <a:solidFill>
                   <a:srgbClr val="A8A29E"/>
                 </a:solidFill>
-                <a:latin typeface="paybooc OTF" pitchFamily="34" charset="0"/>
-                <a:ea typeface="paybooc OTF" pitchFamily="34" charset="-122"/>
-                <a:cs typeface="paybooc OTF" pitchFamily="34" charset="-120"/>
+                <a:latin typeface="Pretendard Light" pitchFamily="34" charset="0"/>
+                <a:ea typeface="Pretendard Light" pitchFamily="34" charset="-122"/>
+                <a:cs typeface="Pretendard Light" pitchFamily="34" charset="-120"/>
               </a:rPr>
               <a:t>→</a:t>
             </a:r>
@@ -18588,9 +18588,9 @@
                 <a:solidFill>
                   <a:srgbClr val="777169"/>
                 </a:solidFill>
-                <a:latin typeface="paybooc OTF" pitchFamily="34" charset="0"/>
-                <a:ea typeface="paybooc OTF" pitchFamily="34" charset="-122"/>
-                <a:cs typeface="paybooc OTF" pitchFamily="34" charset="-120"/>
+                <a:latin typeface="Pretendard Light" pitchFamily="34" charset="0"/>
+                <a:ea typeface="Pretendard Light" pitchFamily="34" charset="-122"/>
+                <a:cs typeface="Pretendard Light" pitchFamily="34" charset="-120"/>
               </a:rPr>
               <a:t>결과</a:t>
             </a:r>
@@ -18739,9 +18739,9 @@
                 <a:solidFill>
                   <a:srgbClr val="DC2626"/>
                 </a:solidFill>
-                <a:latin typeface="paybooc OTF" pitchFamily="34" charset="0"/>
-                <a:ea typeface="paybooc OTF" pitchFamily="34" charset="-122"/>
-                <a:cs typeface="paybooc OTF" pitchFamily="34" charset="-120"/>
+                <a:latin typeface="Pretendard Light" pitchFamily="34" charset="0"/>
+                <a:ea typeface="Pretendard Light" pitchFamily="34" charset="-122"/>
+                <a:cs typeface="Pretendard Light" pitchFamily="34" charset="-120"/>
               </a:rPr>
               <a:t>주의</a:t>
             </a:r>
@@ -19032,9 +19032,9 @@
                 <a:solidFill>
                   <a:srgbClr val="0C0A09"/>
                 </a:solidFill>
-                <a:latin typeface="paybooc OTF" pitchFamily="34" charset="0"/>
-                <a:ea typeface="paybooc OTF" pitchFamily="34" charset="-122"/>
-                <a:cs typeface="paybooc OTF" pitchFamily="34" charset="-120"/>
+                <a:latin typeface="Pretendard Light" pitchFamily="34" charset="0"/>
+                <a:ea typeface="Pretendard Light" pitchFamily="34" charset="-122"/>
+                <a:cs typeface="Pretendard Light" pitchFamily="34" charset="-120"/>
               </a:rPr>
               <a:t>수수 사주교육</a:t>
             </a:r>
@@ -19070,9 +19070,9 @@
                 <a:solidFill>
                   <a:srgbClr val="777169"/>
                 </a:solidFill>
-                <a:latin typeface="paybooc OTF" pitchFamily="34" charset="0"/>
-                <a:ea typeface="paybooc OTF" pitchFamily="34" charset="-122"/>
-                <a:cs typeface="paybooc OTF" pitchFamily="34" charset="-120"/>
+                <a:latin typeface="Pretendard Light" pitchFamily="34" charset="0"/>
+                <a:ea typeface="Pretendard Light" pitchFamily="34" charset="-122"/>
+                <a:cs typeface="Pretendard Light" pitchFamily="34" charset="-120"/>
               </a:rPr>
               <a:t>05</a:t>
             </a:r>
@@ -19108,9 +19108,9 @@
                 <a:solidFill>
                   <a:srgbClr val="777169"/>
                 </a:solidFill>
-                <a:latin typeface="paybooc OTF" pitchFamily="34" charset="0"/>
-                <a:ea typeface="paybooc OTF" pitchFamily="34" charset="-122"/>
-                <a:cs typeface="paybooc OTF" pitchFamily="34" charset="-120"/>
+                <a:latin typeface="Pretendard Light" pitchFamily="34" charset="0"/>
+                <a:ea typeface="Pretendard Light" pitchFamily="34" charset="-122"/>
+                <a:cs typeface="Pretendard Light" pitchFamily="34" charset="-120"/>
               </a:rPr>
               <a:t>05 · 운 해석의 기초</a:t>
             </a:r>
@@ -19184,9 +19184,9 @@
                 <a:solidFill>
                   <a:srgbClr val="777169"/>
                 </a:solidFill>
-                <a:latin typeface="paybooc OTF" pitchFamily="34" charset="0"/>
-                <a:ea typeface="paybooc OTF" pitchFamily="34" charset="-122"/>
-                <a:cs typeface="paybooc OTF" pitchFamily="34" charset="-120"/>
+                <a:latin typeface="Pretendard Light" pitchFamily="34" charset="0"/>
+                <a:ea typeface="Pretendard Light" pitchFamily="34" charset="-122"/>
+                <a:cs typeface="Pretendard Light" pitchFamily="34" charset="-120"/>
               </a:rPr>
               <a:t>이 순서로 보면 흔들리지 않는다</a:t>
             </a:r>
@@ -19316,9 +19316,9 @@
                 <a:solidFill>
                   <a:srgbClr val="0C0A09"/>
                 </a:solidFill>
-                <a:latin typeface="paybooc OTF" pitchFamily="34" charset="0"/>
-                <a:ea typeface="paybooc OTF" pitchFamily="34" charset="-122"/>
-                <a:cs typeface="paybooc OTF" pitchFamily="34" charset="-120"/>
+                <a:latin typeface="Pretendard Light" pitchFamily="34" charset="0"/>
+                <a:ea typeface="Pretendard Light" pitchFamily="34" charset="-122"/>
+                <a:cs typeface="Pretendard Light" pitchFamily="34" charset="-120"/>
               </a:rPr>
               <a:t>원국 파악</a:t>
             </a:r>
@@ -19489,9 +19489,9 @@
                 <a:solidFill>
                   <a:srgbClr val="0C0A09"/>
                 </a:solidFill>
-                <a:latin typeface="paybooc OTF" pitchFamily="34" charset="0"/>
-                <a:ea typeface="paybooc OTF" pitchFamily="34" charset="-122"/>
-                <a:cs typeface="paybooc OTF" pitchFamily="34" charset="-120"/>
+                <a:latin typeface="Pretendard Light" pitchFamily="34" charset="0"/>
+                <a:ea typeface="Pretendard Light" pitchFamily="34" charset="-122"/>
+                <a:cs typeface="Pretendard Light" pitchFamily="34" charset="-120"/>
               </a:rPr>
               <a:t>필요 오행</a:t>
             </a:r>
@@ -19662,9 +19662,9 @@
                 <a:solidFill>
                   <a:srgbClr val="0C0A09"/>
                 </a:solidFill>
-                <a:latin typeface="paybooc OTF" pitchFamily="34" charset="0"/>
-                <a:ea typeface="paybooc OTF" pitchFamily="34" charset="-122"/>
-                <a:cs typeface="paybooc OTF" pitchFamily="34" charset="-120"/>
+                <a:latin typeface="Pretendard Light" pitchFamily="34" charset="0"/>
+                <a:ea typeface="Pretendard Light" pitchFamily="34" charset="-122"/>
+                <a:cs typeface="Pretendard Light" pitchFamily="34" charset="-120"/>
               </a:rPr>
               <a:t>운 글자 대입</a:t>
             </a:r>
@@ -19835,9 +19835,9 @@
                 <a:solidFill>
                   <a:srgbClr val="0C0A09"/>
                 </a:solidFill>
-                <a:latin typeface="paybooc OTF" pitchFamily="34" charset="0"/>
-                <a:ea typeface="paybooc OTF" pitchFamily="34" charset="-122"/>
-                <a:cs typeface="paybooc OTF" pitchFamily="34" charset="-120"/>
+                <a:latin typeface="Pretendard Light" pitchFamily="34" charset="0"/>
+                <a:ea typeface="Pretendard Light" pitchFamily="34" charset="-122"/>
+                <a:cs typeface="Pretendard Light" pitchFamily="34" charset="-120"/>
               </a:rPr>
               <a:t>길흉 판단</a:t>
             </a:r>
@@ -19948,9 +19948,9 @@
                 <a:solidFill>
                   <a:srgbClr val="777169"/>
                 </a:solidFill>
-                <a:latin typeface="paybooc OTF" pitchFamily="34" charset="0"/>
-                <a:ea typeface="paybooc OTF" pitchFamily="34" charset="-122"/>
-                <a:cs typeface="paybooc OTF" pitchFamily="34" charset="-120"/>
+                <a:latin typeface="Pretendard Light" pitchFamily="34" charset="0"/>
+                <a:ea typeface="Pretendard Light" pitchFamily="34" charset="-122"/>
+                <a:cs typeface="Pretendard Light" pitchFamily="34" charset="-120"/>
               </a:rPr>
               <a:t>습관</a:t>
             </a:r>
@@ -20181,9 +20181,9 @@
                 <a:solidFill>
                   <a:srgbClr val="0C0A09"/>
                 </a:solidFill>
-                <a:latin typeface="paybooc OTF" pitchFamily="34" charset="0"/>
-                <a:ea typeface="paybooc OTF" pitchFamily="34" charset="-122"/>
-                <a:cs typeface="paybooc OTF" pitchFamily="34" charset="-120"/>
+                <a:latin typeface="Pretendard Light" pitchFamily="34" charset="0"/>
+                <a:ea typeface="Pretendard Light" pitchFamily="34" charset="-122"/>
+                <a:cs typeface="Pretendard Light" pitchFamily="34" charset="-120"/>
               </a:rPr>
               <a:t>수수 사주교육</a:t>
             </a:r>
@@ -20219,9 +20219,9 @@
                 <a:solidFill>
                   <a:srgbClr val="777169"/>
                 </a:solidFill>
-                <a:latin typeface="paybooc OTF" pitchFamily="34" charset="0"/>
-                <a:ea typeface="paybooc OTF" pitchFamily="34" charset="-122"/>
-                <a:cs typeface="paybooc OTF" pitchFamily="34" charset="-120"/>
+                <a:latin typeface="Pretendard Light" pitchFamily="34" charset="0"/>
+                <a:ea typeface="Pretendard Light" pitchFamily="34" charset="-122"/>
+                <a:cs typeface="Pretendard Light" pitchFamily="34" charset="-120"/>
               </a:rPr>
               <a:t>REVIEW</a:t>
             </a:r>
@@ -20257,9 +20257,9 @@
                 <a:solidFill>
                   <a:srgbClr val="777169"/>
                 </a:solidFill>
-                <a:latin typeface="paybooc OTF" pitchFamily="34" charset="0"/>
-                <a:ea typeface="paybooc OTF" pitchFamily="34" charset="-122"/>
-                <a:cs typeface="paybooc OTF" pitchFamily="34" charset="-120"/>
+                <a:latin typeface="Pretendard Light" pitchFamily="34" charset="0"/>
+                <a:ea typeface="Pretendard Light" pitchFamily="34" charset="-122"/>
+                <a:cs typeface="Pretendard Light" pitchFamily="34" charset="-120"/>
               </a:rPr>
               <a:t>WRAP-UP</a:t>
             </a:r>
@@ -20333,9 +20333,9 @@
                 <a:solidFill>
                   <a:srgbClr val="777169"/>
                 </a:solidFill>
-                <a:latin typeface="paybooc OTF" pitchFamily="34" charset="0"/>
-                <a:ea typeface="paybooc OTF" pitchFamily="34" charset="-122"/>
-                <a:cs typeface="paybooc OTF" pitchFamily="34" charset="-120"/>
+                <a:latin typeface="Pretendard Light" pitchFamily="34" charset="0"/>
+                <a:ea typeface="Pretendard Light" pitchFamily="34" charset="-122"/>
+                <a:cs typeface="Pretendard Light" pitchFamily="34" charset="-120"/>
               </a:rPr>
               <a:t>오늘 꼭 챙길 다섯 가지</a:t>
             </a:r>
@@ -20431,9 +20431,9 @@
                 <a:solidFill>
                   <a:srgbClr val="0C0A09"/>
                 </a:solidFill>
-                <a:latin typeface="paybooc OTF" pitchFamily="34" charset="0"/>
-                <a:ea typeface="paybooc OTF" pitchFamily="34" charset="-122"/>
-                <a:cs typeface="paybooc OTF" pitchFamily="34" charset="-120"/>
+                <a:latin typeface="Pretendard Light" pitchFamily="34" charset="0"/>
+                <a:ea typeface="Pretendard Light" pitchFamily="34" charset="-122"/>
+                <a:cs typeface="Pretendard Light" pitchFamily="34" charset="-120"/>
               </a:rPr>
               <a:t>원국은 “차”, 운은 “길”</a:t>
             </a:r>
@@ -20590,9 +20590,9 @@
                 <a:solidFill>
                   <a:srgbClr val="0C0A09"/>
                 </a:solidFill>
-                <a:latin typeface="paybooc OTF" pitchFamily="34" charset="0"/>
-                <a:ea typeface="paybooc OTF" pitchFamily="34" charset="-122"/>
-                <a:cs typeface="paybooc OTF" pitchFamily="34" charset="-120"/>
+                <a:latin typeface="Pretendard Light" pitchFamily="34" charset="0"/>
+                <a:ea typeface="Pretendard Light" pitchFamily="34" charset="-122"/>
+                <a:cs typeface="Pretendard Light" pitchFamily="34" charset="-120"/>
               </a:rPr>
               <a:t>대운 = 10년 단위 큰 환경</a:t>
             </a:r>
@@ -20749,9 +20749,9 @@
                 <a:solidFill>
                   <a:srgbClr val="0C0A09"/>
                 </a:solidFill>
-                <a:latin typeface="paybooc OTF" pitchFamily="34" charset="0"/>
-                <a:ea typeface="paybooc OTF" pitchFamily="34" charset="-122"/>
-                <a:cs typeface="paybooc OTF" pitchFamily="34" charset="-120"/>
+                <a:latin typeface="Pretendard Light" pitchFamily="34" charset="0"/>
+                <a:ea typeface="Pretendard Light" pitchFamily="34" charset="-122"/>
+                <a:cs typeface="Pretendard Light" pitchFamily="34" charset="-120"/>
               </a:rPr>
               <a:t>세운 = 1년 단위 그해 사건</a:t>
             </a:r>
@@ -20908,9 +20908,9 @@
                 <a:solidFill>
                   <a:srgbClr val="0C0A09"/>
                 </a:solidFill>
-                <a:latin typeface="paybooc OTF" pitchFamily="34" charset="0"/>
-                <a:ea typeface="paybooc OTF" pitchFamily="34" charset="-122"/>
-                <a:cs typeface="paybooc OTF" pitchFamily="34" charset="-120"/>
+                <a:latin typeface="Pretendard Light" pitchFamily="34" charset="0"/>
+                <a:ea typeface="Pretendard Light" pitchFamily="34" charset="-122"/>
+                <a:cs typeface="Pretendard Light" pitchFamily="34" charset="-120"/>
               </a:rPr>
               <a:t>만세력은 대운수→대운→세운 순</a:t>
             </a:r>
@@ -21067,9 +21067,9 @@
                 <a:solidFill>
                   <a:srgbClr val="0C0A09"/>
                 </a:solidFill>
-                <a:latin typeface="paybooc OTF" pitchFamily="34" charset="0"/>
-                <a:ea typeface="paybooc OTF" pitchFamily="34" charset="-122"/>
-                <a:cs typeface="paybooc OTF" pitchFamily="34" charset="-120"/>
+                <a:latin typeface="Pretendard Light" pitchFamily="34" charset="0"/>
+                <a:ea typeface="Pretendard Light" pitchFamily="34" charset="-122"/>
+                <a:cs typeface="Pretendard Light" pitchFamily="34" charset="-120"/>
               </a:rPr>
               <a:t>필요오행이면 순풍, 부담이면 역풍</a:t>
             </a:r>
@@ -21319,9 +21319,9 @@
                 <a:solidFill>
                   <a:srgbClr val="0C0A09"/>
                 </a:solidFill>
-                <a:latin typeface="paybooc OTF" pitchFamily="34" charset="0"/>
-                <a:ea typeface="paybooc OTF" pitchFamily="34" charset="-122"/>
-                <a:cs typeface="paybooc OTF" pitchFamily="34" charset="-120"/>
+                <a:latin typeface="Pretendard Light" pitchFamily="34" charset="0"/>
+                <a:ea typeface="Pretendard Light" pitchFamily="34" charset="-122"/>
+                <a:cs typeface="Pretendard Light" pitchFamily="34" charset="-120"/>
               </a:rPr>
               <a:t>수수 사주교육</a:t>
             </a:r>
@@ -21357,9 +21357,9 @@
                 <a:solidFill>
                   <a:srgbClr val="777169"/>
                 </a:solidFill>
-                <a:latin typeface="paybooc OTF" pitchFamily="34" charset="0"/>
-                <a:ea typeface="paybooc OTF" pitchFamily="34" charset="-122"/>
-                <a:cs typeface="paybooc OTF" pitchFamily="34" charset="-120"/>
+                <a:latin typeface="Pretendard Light" pitchFamily="34" charset="0"/>
+                <a:ea typeface="Pretendard Light" pitchFamily="34" charset="-122"/>
+                <a:cs typeface="Pretendard Light" pitchFamily="34" charset="-120"/>
               </a:rPr>
               <a:t>GOALS</a:t>
             </a:r>
@@ -21395,9 +21395,9 @@
                 <a:solidFill>
                   <a:srgbClr val="777169"/>
                 </a:solidFill>
-                <a:latin typeface="paybooc OTF" pitchFamily="34" charset="0"/>
-                <a:ea typeface="paybooc OTF" pitchFamily="34" charset="-122"/>
-                <a:cs typeface="paybooc OTF" pitchFamily="34" charset="-120"/>
+                <a:latin typeface="Pretendard Light" pitchFamily="34" charset="0"/>
+                <a:ea typeface="Pretendard Light" pitchFamily="34" charset="-122"/>
+                <a:cs typeface="Pretendard Light" pitchFamily="34" charset="-120"/>
               </a:rPr>
               <a:t>LEARNING GOALS</a:t>
             </a:r>
@@ -21471,9 +21471,9 @@
                 <a:solidFill>
                   <a:srgbClr val="777169"/>
                 </a:solidFill>
-                <a:latin typeface="paybooc OTF" pitchFamily="34" charset="0"/>
-                <a:ea typeface="paybooc OTF" pitchFamily="34" charset="-122"/>
-                <a:cs typeface="paybooc OTF" pitchFamily="34" charset="-120"/>
+                <a:latin typeface="Pretendard Light" pitchFamily="34" charset="0"/>
+                <a:ea typeface="Pretendard Light" pitchFamily="34" charset="-122"/>
+                <a:cs typeface="Pretendard Light" pitchFamily="34" charset="-120"/>
               </a:rPr>
               <a:t>끝나면 이 세 가지를 할 수 있습니다</a:t>
             </a:r>
@@ -21603,9 +21603,9 @@
                 <a:solidFill>
                   <a:srgbClr val="0C0A09"/>
                 </a:solidFill>
-                <a:latin typeface="paybooc OTF" pitchFamily="34" charset="0"/>
-                <a:ea typeface="paybooc OTF" pitchFamily="34" charset="-122"/>
-                <a:cs typeface="paybooc OTF" pitchFamily="34" charset="-120"/>
+                <a:latin typeface="Pretendard Light" pitchFamily="34" charset="0"/>
+                <a:ea typeface="Pretendard Light" pitchFamily="34" charset="-122"/>
+                <a:cs typeface="Pretendard Light" pitchFamily="34" charset="-120"/>
               </a:rPr>
               <a:t>운의 관점 잡기</a:t>
             </a:r>
@@ -21776,9 +21776,9 @@
                 <a:solidFill>
                   <a:srgbClr val="0C0A09"/>
                 </a:solidFill>
-                <a:latin typeface="paybooc OTF" pitchFamily="34" charset="0"/>
-                <a:ea typeface="paybooc OTF" pitchFamily="34" charset="-122"/>
-                <a:cs typeface="paybooc OTF" pitchFamily="34" charset="-120"/>
+                <a:latin typeface="Pretendard Light" pitchFamily="34" charset="0"/>
+                <a:ea typeface="Pretendard Light" pitchFamily="34" charset="-122"/>
+                <a:cs typeface="Pretendard Light" pitchFamily="34" charset="-120"/>
               </a:rPr>
               <a:t>대운·세운 구분</a:t>
             </a:r>
@@ -21949,9 +21949,9 @@
                 <a:solidFill>
                   <a:srgbClr val="0C0A09"/>
                 </a:solidFill>
-                <a:latin typeface="paybooc OTF" pitchFamily="34" charset="0"/>
-                <a:ea typeface="paybooc OTF" pitchFamily="34" charset="-122"/>
-                <a:cs typeface="paybooc OTF" pitchFamily="34" charset="-120"/>
+                <a:latin typeface="Pretendard Light" pitchFamily="34" charset="0"/>
+                <a:ea typeface="Pretendard Light" pitchFamily="34" charset="-122"/>
+                <a:cs typeface="Pretendard Light" pitchFamily="34" charset="-120"/>
               </a:rPr>
               <a:t>만세력 판독</a:t>
             </a:r>
@@ -22062,9 +22062,9 @@
                 <a:solidFill>
                   <a:srgbClr val="777169"/>
                 </a:solidFill>
-                <a:latin typeface="paybooc OTF" pitchFamily="34" charset="0"/>
-                <a:ea typeface="paybooc OTF" pitchFamily="34" charset="-122"/>
-                <a:cs typeface="paybooc OTF" pitchFamily="34" charset="-120"/>
+                <a:latin typeface="Pretendard Light" pitchFamily="34" charset="0"/>
+                <a:ea typeface="Pretendard Light" pitchFamily="34" charset="-122"/>
+                <a:cs typeface="Pretendard Light" pitchFamily="34" charset="-120"/>
               </a:rPr>
               <a:t>한 줄 요약</a:t>
             </a:r>
@@ -22339,9 +22339,9 @@
                 <a:solidFill>
                   <a:srgbClr val="FFFFFF"/>
                 </a:solidFill>
-                <a:latin typeface="paybooc OTF" pitchFamily="34" charset="0"/>
-                <a:ea typeface="paybooc OTF" pitchFamily="34" charset="-122"/>
-                <a:cs typeface="paybooc OTF" pitchFamily="34" charset="-120"/>
+                <a:latin typeface="Pretendard Light" pitchFamily="34" charset="0"/>
+                <a:ea typeface="Pretendard Light" pitchFamily="34" charset="-122"/>
+                <a:cs typeface="Pretendard Light" pitchFamily="34" charset="-120"/>
               </a:rPr>
               <a:t>수수 사주교육</a:t>
             </a:r>
@@ -22377,9 +22377,9 @@
                 <a:solidFill>
                   <a:srgbClr val="A8A29E"/>
                 </a:solidFill>
-                <a:latin typeface="paybooc OTF" pitchFamily="34" charset="0"/>
-                <a:ea typeface="paybooc OTF" pitchFamily="34" charset="-122"/>
-                <a:cs typeface="paybooc OTF" pitchFamily="34" charset="-120"/>
+                <a:latin typeface="Pretendard Light" pitchFamily="34" charset="0"/>
+                <a:ea typeface="Pretendard Light" pitchFamily="34" charset="-122"/>
+                <a:cs typeface="Pretendard Light" pitchFamily="34" charset="-120"/>
               </a:rPr>
               <a:t>NEXT SESSION</a:t>
             </a:r>
@@ -22415,9 +22415,9 @@
                 <a:solidFill>
                   <a:srgbClr val="A7E5D3"/>
                 </a:solidFill>
-                <a:latin typeface="paybooc OTF" pitchFamily="34" charset="0"/>
-                <a:ea typeface="paybooc OTF" pitchFamily="34" charset="-122"/>
-                <a:cs typeface="paybooc OTF" pitchFamily="34" charset="-120"/>
+                <a:latin typeface="Pretendard Light" pitchFamily="34" charset="0"/>
+                <a:ea typeface="Pretendard Light" pitchFamily="34" charset="-122"/>
+                <a:cs typeface="Pretendard Light" pitchFamily="34" charset="-120"/>
               </a:rPr>
               <a:t>다음 시간</a:t>
             </a:r>
@@ -22491,9 +22491,9 @@
                 <a:solidFill>
                   <a:srgbClr val="A8A29E"/>
                 </a:solidFill>
-                <a:latin typeface="paybooc OTF" pitchFamily="34" charset="0"/>
-                <a:ea typeface="paybooc OTF" pitchFamily="34" charset="-122"/>
-                <a:cs typeface="paybooc OTF" pitchFamily="34" charset="-120"/>
+                <a:latin typeface="Pretendard Light" pitchFamily="34" charset="0"/>
+                <a:ea typeface="Pretendard Light" pitchFamily="34" charset="-122"/>
+                <a:cs typeface="Pretendard Light" pitchFamily="34" charset="-120"/>
               </a:rPr>
               <a:t>오늘 읽은 대운·세운 위에, 용신(用神)으로 길흉을 더 정교하게</a:t>
             </a:r>
@@ -22594,9 +22594,9 @@
                 <a:solidFill>
                   <a:srgbClr val="FFFFFF"/>
                 </a:solidFill>
-                <a:latin typeface="paybooc OTF" pitchFamily="34" charset="0"/>
-                <a:ea typeface="paybooc OTF" pitchFamily="34" charset="-122"/>
-                <a:cs typeface="paybooc OTF" pitchFamily="34" charset="-120"/>
+                <a:latin typeface="Pretendard Light" pitchFamily="34" charset="0"/>
+                <a:ea typeface="Pretendard Light" pitchFamily="34" charset="-122"/>
+                <a:cs typeface="Pretendard Light" pitchFamily="34" charset="-120"/>
               </a:rPr>
               <a:t>용신·희신·기신</a:t>
             </a:r>
@@ -22735,9 +22735,9 @@
                 <a:solidFill>
                   <a:srgbClr val="FFFFFF"/>
                 </a:solidFill>
-                <a:latin typeface="paybooc OTF" pitchFamily="34" charset="0"/>
-                <a:ea typeface="paybooc OTF" pitchFamily="34" charset="-122"/>
-                <a:cs typeface="paybooc OTF" pitchFamily="34" charset="-120"/>
+                <a:latin typeface="Pretendard Light" pitchFamily="34" charset="0"/>
+                <a:ea typeface="Pretendard Light" pitchFamily="34" charset="-122"/>
+                <a:cs typeface="Pretendard Light" pitchFamily="34" charset="-120"/>
               </a:rPr>
               <a:t>십신(十神)으로 보는 사건</a:t>
             </a:r>
@@ -22876,9 +22876,9 @@
                 <a:solidFill>
                   <a:srgbClr val="FFFFFF"/>
                 </a:solidFill>
-                <a:latin typeface="paybooc OTF" pitchFamily="34" charset="0"/>
-                <a:ea typeface="paybooc OTF" pitchFamily="34" charset="-122"/>
-                <a:cs typeface="paybooc OTF" pitchFamily="34" charset="-120"/>
+                <a:latin typeface="Pretendard Light" pitchFamily="34" charset="0"/>
+                <a:ea typeface="Pretendard Light" pitchFamily="34" charset="-122"/>
+                <a:cs typeface="Pretendard Light" pitchFamily="34" charset="-120"/>
               </a:rPr>
               <a:t>합·충·형</a:t>
             </a:r>
@@ -23106,9 +23106,9 @@
                 <a:solidFill>
                   <a:srgbClr val="0C0A09"/>
                 </a:solidFill>
-                <a:latin typeface="paybooc OTF" pitchFamily="34" charset="0"/>
-                <a:ea typeface="paybooc OTF" pitchFamily="34" charset="-122"/>
-                <a:cs typeface="paybooc OTF" pitchFamily="34" charset="-120"/>
+                <a:latin typeface="Pretendard Light" pitchFamily="34" charset="0"/>
+                <a:ea typeface="Pretendard Light" pitchFamily="34" charset="-122"/>
+                <a:cs typeface="Pretendard Light" pitchFamily="34" charset="-120"/>
               </a:rPr>
               <a:t>수수 사주교육</a:t>
             </a:r>
@@ -23144,9 +23144,9 @@
                 <a:solidFill>
                   <a:srgbClr val="777169"/>
                 </a:solidFill>
-                <a:latin typeface="paybooc OTF" pitchFamily="34" charset="0"/>
-                <a:ea typeface="paybooc OTF" pitchFamily="34" charset="-122"/>
-                <a:cs typeface="paybooc OTF" pitchFamily="34" charset="-120"/>
+                <a:latin typeface="Pretendard Light" pitchFamily="34" charset="0"/>
+                <a:ea typeface="Pretendard Light" pitchFamily="34" charset="-122"/>
+                <a:cs typeface="Pretendard Light" pitchFamily="34" charset="-120"/>
               </a:rPr>
               <a:t>RECAP · 1회차</a:t>
             </a:r>
@@ -23182,9 +23182,9 @@
                 <a:solidFill>
                   <a:srgbClr val="777169"/>
                 </a:solidFill>
-                <a:latin typeface="paybooc OTF" pitchFamily="34" charset="0"/>
-                <a:ea typeface="paybooc OTF" pitchFamily="34" charset="-122"/>
-                <a:cs typeface="paybooc OTF" pitchFamily="34" charset="-120"/>
+                <a:latin typeface="Pretendard Light" pitchFamily="34" charset="0"/>
+                <a:ea typeface="Pretendard Light" pitchFamily="34" charset="-122"/>
+                <a:cs typeface="Pretendard Light" pitchFamily="34" charset="-120"/>
               </a:rPr>
               <a:t>BRIDGE FROM SESSION 01</a:t>
             </a:r>
@@ -23258,9 +23258,9 @@
                 <a:solidFill>
                   <a:srgbClr val="777169"/>
                 </a:solidFill>
-                <a:latin typeface="paybooc OTF" pitchFamily="34" charset="0"/>
-                <a:ea typeface="paybooc OTF" pitchFamily="34" charset="-122"/>
-                <a:cs typeface="paybooc OTF" pitchFamily="34" charset="-120"/>
+                <a:latin typeface="Pretendard Light" pitchFamily="34" charset="0"/>
+                <a:ea typeface="Pretendard Light" pitchFamily="34" charset="-122"/>
+                <a:cs typeface="Pretendard Light" pitchFamily="34" charset="-120"/>
               </a:rPr>
               <a:t>운을 읽으려면 먼저 내 “차”를 알아야 한다</a:t>
             </a:r>
@@ -23330,9 +23330,9 @@
                 <a:solidFill>
                   <a:srgbClr val="777169"/>
                 </a:solidFill>
-                <a:latin typeface="paybooc OTF" pitchFamily="34" charset="0"/>
-                <a:ea typeface="paybooc OTF" pitchFamily="34" charset="-122"/>
-                <a:cs typeface="paybooc OTF" pitchFamily="34" charset="-120"/>
+                <a:latin typeface="Pretendard Light" pitchFamily="34" charset="0"/>
+                <a:ea typeface="Pretendard Light" pitchFamily="34" charset="-122"/>
+                <a:cs typeface="Pretendard Light" pitchFamily="34" charset="-120"/>
               </a:rPr>
               <a:t>ORIGIN</a:t>
             </a:r>
@@ -23368,9 +23368,9 @@
                 <a:solidFill>
                   <a:srgbClr val="0C0A09"/>
                 </a:solidFill>
-                <a:latin typeface="paybooc OTF" pitchFamily="34" charset="0"/>
-                <a:ea typeface="paybooc OTF" pitchFamily="34" charset="-122"/>
-                <a:cs typeface="paybooc OTF" pitchFamily="34" charset="-120"/>
+                <a:latin typeface="Pretendard Light" pitchFamily="34" charset="0"/>
+                <a:ea typeface="Pretendard Light" pitchFamily="34" charset="-122"/>
+                <a:cs typeface="Pretendard Light" pitchFamily="34" charset="-120"/>
               </a:rPr>
               <a:t>여덟 글자(팔자)</a:t>
             </a:r>
@@ -23481,9 +23481,9 @@
                 <a:solidFill>
                   <a:srgbClr val="777169"/>
                 </a:solidFill>
-                <a:latin typeface="paybooc OTF" pitchFamily="34" charset="0"/>
-                <a:ea typeface="paybooc OTF" pitchFamily="34" charset="-122"/>
-                <a:cs typeface="paybooc OTF" pitchFamily="34" charset="-120"/>
+                <a:latin typeface="Pretendard Light" pitchFamily="34" charset="0"/>
+                <a:ea typeface="Pretendard Light" pitchFamily="34" charset="-122"/>
+                <a:cs typeface="Pretendard Light" pitchFamily="34" charset="-120"/>
               </a:rPr>
               <a:t>BALANCE</a:t>
             </a:r>
@@ -23519,9 +23519,9 @@
                 <a:solidFill>
                   <a:srgbClr val="0C0A09"/>
                 </a:solidFill>
-                <a:latin typeface="paybooc OTF" pitchFamily="34" charset="0"/>
-                <a:ea typeface="paybooc OTF" pitchFamily="34" charset="-122"/>
-                <a:cs typeface="paybooc OTF" pitchFamily="34" charset="-120"/>
+                <a:latin typeface="Pretendard Light" pitchFamily="34" charset="0"/>
+                <a:ea typeface="Pretendard Light" pitchFamily="34" charset="-122"/>
+                <a:cs typeface="Pretendard Light" pitchFamily="34" charset="-120"/>
               </a:rPr>
               <a:t>오행의 균형</a:t>
             </a:r>
@@ -23632,9 +23632,9 @@
                 <a:solidFill>
                   <a:srgbClr val="777169"/>
                 </a:solidFill>
-                <a:latin typeface="paybooc OTF" pitchFamily="34" charset="0"/>
-                <a:ea typeface="paybooc OTF" pitchFamily="34" charset="-122"/>
-                <a:cs typeface="paybooc OTF" pitchFamily="34" charset="-120"/>
+                <a:latin typeface="Pretendard Light" pitchFamily="34" charset="0"/>
+                <a:ea typeface="Pretendard Light" pitchFamily="34" charset="-122"/>
+                <a:cs typeface="Pretendard Light" pitchFamily="34" charset="-120"/>
               </a:rPr>
               <a:t>ME</a:t>
             </a:r>
@@ -23670,9 +23670,9 @@
                 <a:solidFill>
                   <a:srgbClr val="0C0A09"/>
                 </a:solidFill>
-                <a:latin typeface="paybooc OTF" pitchFamily="34" charset="0"/>
-                <a:ea typeface="paybooc OTF" pitchFamily="34" charset="-122"/>
-                <a:cs typeface="paybooc OTF" pitchFamily="34" charset="-120"/>
+                <a:latin typeface="Pretendard Light" pitchFamily="34" charset="0"/>
+                <a:ea typeface="Pretendard Light" pitchFamily="34" charset="-122"/>
+                <a:cs typeface="Pretendard Light" pitchFamily="34" charset="-120"/>
               </a:rPr>
               <a:t>일간(日干) = 나</a:t>
             </a:r>
@@ -23783,9 +23783,9 @@
                 <a:solidFill>
                   <a:srgbClr val="777169"/>
                 </a:solidFill>
-                <a:latin typeface="paybooc OTF" pitchFamily="34" charset="0"/>
-                <a:ea typeface="paybooc OTF" pitchFamily="34" charset="-122"/>
-                <a:cs typeface="paybooc OTF" pitchFamily="34" charset="-120"/>
+                <a:latin typeface="Pretendard Light" pitchFamily="34" charset="0"/>
+                <a:ea typeface="Pretendard Light" pitchFamily="34" charset="-122"/>
+                <a:cs typeface="Pretendard Light" pitchFamily="34" charset="-120"/>
               </a:rPr>
               <a:t>연결</a:t>
             </a:r>
@@ -24038,9 +24038,9 @@
                 <a:solidFill>
                   <a:srgbClr val="0C0A09"/>
                 </a:solidFill>
-                <a:latin typeface="paybooc OTF" pitchFamily="34" charset="0"/>
-                <a:ea typeface="paybooc OTF" pitchFamily="34" charset="-122"/>
-                <a:cs typeface="paybooc OTF" pitchFamily="34" charset="-120"/>
+                <a:latin typeface="Pretendard Light" pitchFamily="34" charset="0"/>
+                <a:ea typeface="Pretendard Light" pitchFamily="34" charset="-122"/>
+                <a:cs typeface="Pretendard Light" pitchFamily="34" charset="-120"/>
               </a:rPr>
               <a:t>수수 사주교육</a:t>
             </a:r>
@@ -24076,9 +24076,9 @@
                 <a:solidFill>
                   <a:srgbClr val="777169"/>
                 </a:solidFill>
-                <a:latin typeface="paybooc OTF" pitchFamily="34" charset="0"/>
-                <a:ea typeface="paybooc OTF" pitchFamily="34" charset="-122"/>
-                <a:cs typeface="paybooc OTF" pitchFamily="34" charset="-120"/>
+                <a:latin typeface="Pretendard Light" pitchFamily="34" charset="0"/>
+                <a:ea typeface="Pretendard Light" pitchFamily="34" charset="-122"/>
+                <a:cs typeface="Pretendard Light" pitchFamily="34" charset="-120"/>
               </a:rPr>
               <a:t>SECTION 01</a:t>
             </a:r>
@@ -24114,9 +24114,9 @@
                 <a:solidFill>
                   <a:srgbClr val="777169"/>
                 </a:solidFill>
-                <a:latin typeface="paybooc OTF" pitchFamily="34" charset="0"/>
-                <a:ea typeface="paybooc OTF" pitchFamily="34" charset="-122"/>
-                <a:cs typeface="paybooc OTF" pitchFamily="34" charset="-120"/>
+                <a:latin typeface="Pretendard Light" pitchFamily="34" charset="0"/>
+                <a:ea typeface="Pretendard Light" pitchFamily="34" charset="-122"/>
+                <a:cs typeface="Pretendard Light" pitchFamily="34" charset="-120"/>
               </a:rPr>
               <a:t>SECTION 01</a:t>
             </a:r>
@@ -24190,9 +24190,9 @@
                 <a:solidFill>
                   <a:srgbClr val="A8A29E"/>
                 </a:solidFill>
-                <a:latin typeface="paybooc OTF" pitchFamily="34" charset="0"/>
-                <a:ea typeface="paybooc OTF" pitchFamily="34" charset="-122"/>
-                <a:cs typeface="paybooc OTF" pitchFamily="34" charset="-120"/>
+                <a:latin typeface="Pretendard Light" pitchFamily="34" charset="0"/>
+                <a:ea typeface="Pretendard Light" pitchFamily="34" charset="-122"/>
+                <a:cs typeface="Pretendard Light" pitchFamily="34" charset="-120"/>
               </a:rPr>
               <a:t>FIXED CHART vs FLOWING LUCK</a:t>
             </a:r>
@@ -24445,9 +24445,9 @@
                 <a:solidFill>
                   <a:srgbClr val="0C0A09"/>
                 </a:solidFill>
-                <a:latin typeface="paybooc OTF" pitchFamily="34" charset="0"/>
-                <a:ea typeface="paybooc OTF" pitchFamily="34" charset="-122"/>
-                <a:cs typeface="paybooc OTF" pitchFamily="34" charset="-120"/>
+                <a:latin typeface="Pretendard Light" pitchFamily="34" charset="0"/>
+                <a:ea typeface="Pretendard Light" pitchFamily="34" charset="-122"/>
+                <a:cs typeface="Pretendard Light" pitchFamily="34" charset="-120"/>
               </a:rPr>
               <a:t>수수 사주교육</a:t>
             </a:r>
@@ -24483,9 +24483,9 @@
                 <a:solidFill>
                   <a:srgbClr val="777169"/>
                 </a:solidFill>
-                <a:latin typeface="paybooc OTF" pitchFamily="34" charset="0"/>
-                <a:ea typeface="paybooc OTF" pitchFamily="34" charset="-122"/>
-                <a:cs typeface="paybooc OTF" pitchFamily="34" charset="-120"/>
+                <a:latin typeface="Pretendard Light" pitchFamily="34" charset="0"/>
+                <a:ea typeface="Pretendard Light" pitchFamily="34" charset="-122"/>
+                <a:cs typeface="Pretendard Light" pitchFamily="34" charset="-120"/>
               </a:rPr>
               <a:t>01</a:t>
             </a:r>
@@ -24521,9 +24521,9 @@
                 <a:solidFill>
                   <a:srgbClr val="777169"/>
                 </a:solidFill>
-                <a:latin typeface="paybooc OTF" pitchFamily="34" charset="0"/>
-                <a:ea typeface="paybooc OTF" pitchFamily="34" charset="-122"/>
-                <a:cs typeface="paybooc OTF" pitchFamily="34" charset="-120"/>
+                <a:latin typeface="Pretendard Light" pitchFamily="34" charset="0"/>
+                <a:ea typeface="Pretendard Light" pitchFamily="34" charset="-122"/>
+                <a:cs typeface="Pretendard Light" pitchFamily="34" charset="-120"/>
               </a:rPr>
               <a:t>01 · 사주와 운의 관계</a:t>
             </a:r>
@@ -24597,9 +24597,9 @@
                 <a:solidFill>
                   <a:srgbClr val="777169"/>
                 </a:solidFill>
-                <a:latin typeface="paybooc OTF" pitchFamily="34" charset="0"/>
-                <a:ea typeface="paybooc OTF" pitchFamily="34" charset="-122"/>
-                <a:cs typeface="paybooc OTF" pitchFamily="34" charset="-120"/>
+                <a:latin typeface="Pretendard Light" pitchFamily="34" charset="0"/>
+                <a:ea typeface="Pretendard Light" pitchFamily="34" charset="-122"/>
+                <a:cs typeface="Pretendard Light" pitchFamily="34" charset="-120"/>
               </a:rPr>
               <a:t>타고난 것과 흘러오는 것</a:t>
             </a:r>
@@ -24691,9 +24691,9 @@
                 <a:solidFill>
                   <a:srgbClr val="777169"/>
                 </a:solidFill>
-                <a:latin typeface="paybooc OTF" pitchFamily="34" charset="0"/>
-                <a:ea typeface="paybooc OTF" pitchFamily="34" charset="-122"/>
-                <a:cs typeface="paybooc OTF" pitchFamily="34" charset="-120"/>
+                <a:latin typeface="Pretendard Light" pitchFamily="34" charset="0"/>
+                <a:ea typeface="Pretendard Light" pitchFamily="34" charset="-122"/>
+                <a:cs typeface="Pretendard Light" pitchFamily="34" charset="-120"/>
               </a:rPr>
               <a:t>ORIGIN · 원국</a:t>
             </a:r>
@@ -24729,9 +24729,9 @@
                 <a:solidFill>
                   <a:srgbClr val="0C0A09"/>
                 </a:solidFill>
-                <a:latin typeface="paybooc OTF" pitchFamily="34" charset="0"/>
-                <a:ea typeface="paybooc OTF" pitchFamily="34" charset="-122"/>
-                <a:cs typeface="paybooc OTF" pitchFamily="34" charset="-120"/>
+                <a:latin typeface="Pretendard Light" pitchFamily="34" charset="0"/>
+                <a:ea typeface="Pretendard Light" pitchFamily="34" charset="-122"/>
+                <a:cs typeface="Pretendard Light" pitchFamily="34" charset="-120"/>
               </a:rPr>
               <a:t>바뀌지 않는 나</a:t>
             </a:r>
@@ -24925,9 +24925,9 @@
                 <a:solidFill>
                   <a:srgbClr val="777169"/>
                 </a:solidFill>
-                <a:latin typeface="paybooc OTF" pitchFamily="34" charset="0"/>
-                <a:ea typeface="paybooc OTF" pitchFamily="34" charset="-122"/>
-                <a:cs typeface="paybooc OTF" pitchFamily="34" charset="-120"/>
+                <a:latin typeface="Pretendard Light" pitchFamily="34" charset="0"/>
+                <a:ea typeface="Pretendard Light" pitchFamily="34" charset="-122"/>
+                <a:cs typeface="Pretendard Light" pitchFamily="34" charset="-120"/>
               </a:rPr>
               <a:t>LUCK · 운</a:t>
             </a:r>
@@ -24963,9 +24963,9 @@
                 <a:solidFill>
                   <a:srgbClr val="0C0A09"/>
                 </a:solidFill>
-                <a:latin typeface="paybooc OTF" pitchFamily="34" charset="0"/>
-                <a:ea typeface="paybooc OTF" pitchFamily="34" charset="-122"/>
-                <a:cs typeface="paybooc OTF" pitchFamily="34" charset="-120"/>
+                <a:latin typeface="Pretendard Light" pitchFamily="34" charset="0"/>
+                <a:ea typeface="Pretendard Light" pitchFamily="34" charset="-122"/>
+                <a:cs typeface="Pretendard Light" pitchFamily="34" charset="-120"/>
               </a:rPr>
               <a:t>흘러가는 환경</a:t>
             </a:r>
@@ -25257,9 +25257,9 @@
                 <a:solidFill>
                   <a:srgbClr val="0C0A09"/>
                 </a:solidFill>
-                <a:latin typeface="paybooc OTF" pitchFamily="34" charset="0"/>
-                <a:ea typeface="paybooc OTF" pitchFamily="34" charset="-122"/>
-                <a:cs typeface="paybooc OTF" pitchFamily="34" charset="-120"/>
+                <a:latin typeface="Pretendard Light" pitchFamily="34" charset="0"/>
+                <a:ea typeface="Pretendard Light" pitchFamily="34" charset="-122"/>
+                <a:cs typeface="Pretendard Light" pitchFamily="34" charset="-120"/>
               </a:rPr>
               <a:t>수수 사주교육</a:t>
             </a:r>
@@ -25295,9 +25295,9 @@
                 <a:solidFill>
                   <a:srgbClr val="777169"/>
                 </a:solidFill>
-                <a:latin typeface="paybooc OTF" pitchFamily="34" charset="0"/>
-                <a:ea typeface="paybooc OTF" pitchFamily="34" charset="-122"/>
-                <a:cs typeface="paybooc OTF" pitchFamily="34" charset="-120"/>
+                <a:latin typeface="Pretendard Light" pitchFamily="34" charset="0"/>
+                <a:ea typeface="Pretendard Light" pitchFamily="34" charset="-122"/>
+                <a:cs typeface="Pretendard Light" pitchFamily="34" charset="-120"/>
               </a:rPr>
               <a:t>01</a:t>
             </a:r>
@@ -25333,9 +25333,9 @@
                 <a:solidFill>
                   <a:srgbClr val="777169"/>
                 </a:solidFill>
-                <a:latin typeface="paybooc OTF" pitchFamily="34" charset="0"/>
-                <a:ea typeface="paybooc OTF" pitchFamily="34" charset="-122"/>
-                <a:cs typeface="paybooc OTF" pitchFamily="34" charset="-120"/>
+                <a:latin typeface="Pretendard Light" pitchFamily="34" charset="0"/>
+                <a:ea typeface="Pretendard Light" pitchFamily="34" charset="-122"/>
+                <a:cs typeface="Pretendard Light" pitchFamily="34" charset="-120"/>
               </a:rPr>
               <a:t>01 · 사주와 운의 관계</a:t>
             </a:r>
@@ -25409,9 +25409,9 @@
                 <a:solidFill>
                   <a:srgbClr val="777169"/>
                 </a:solidFill>
-                <a:latin typeface="paybooc OTF" pitchFamily="34" charset="0"/>
-                <a:ea typeface="paybooc OTF" pitchFamily="34" charset="-122"/>
-                <a:cs typeface="paybooc OTF" pitchFamily="34" charset="-120"/>
+                <a:latin typeface="Pretendard Light" pitchFamily="34" charset="0"/>
+                <a:ea typeface="Pretendard Light" pitchFamily="34" charset="-122"/>
+                <a:cs typeface="Pretendard Light" pitchFamily="34" charset="-120"/>
               </a:rPr>
               <a:t>같은 차라도 길이 다르면 결과가 다르다</a:t>
             </a:r>
@@ -25541,9 +25541,9 @@
                 <a:solidFill>
                   <a:srgbClr val="0C0A09"/>
                 </a:solidFill>
-                <a:latin typeface="paybooc OTF" pitchFamily="34" charset="0"/>
-                <a:ea typeface="paybooc OTF" pitchFamily="34" charset="-122"/>
-                <a:cs typeface="paybooc OTF" pitchFamily="34" charset="-120"/>
+                <a:latin typeface="Pretendard Light" pitchFamily="34" charset="0"/>
+                <a:ea typeface="Pretendard Light" pitchFamily="34" charset="-122"/>
+                <a:cs typeface="Pretendard Light" pitchFamily="34" charset="-120"/>
               </a:rPr>
               <a:t>사주 = 자동차</a:t>
             </a:r>
@@ -25752,9 +25752,9 @@
                 <a:solidFill>
                   <a:srgbClr val="0C0A09"/>
                 </a:solidFill>
-                <a:latin typeface="paybooc OTF" pitchFamily="34" charset="0"/>
-                <a:ea typeface="paybooc OTF" pitchFamily="34" charset="-122"/>
-                <a:cs typeface="paybooc OTF" pitchFamily="34" charset="-120"/>
+                <a:latin typeface="Pretendard Light" pitchFamily="34" charset="0"/>
+                <a:ea typeface="Pretendard Light" pitchFamily="34" charset="-122"/>
+                <a:cs typeface="Pretendard Light" pitchFamily="34" charset="-120"/>
               </a:rPr>
               <a:t>운 = 도로</a:t>
             </a:r>
@@ -25903,9 +25903,9 @@
                 <a:solidFill>
                   <a:srgbClr val="777169"/>
                 </a:solidFill>
-                <a:latin typeface="paybooc OTF" pitchFamily="34" charset="0"/>
-                <a:ea typeface="paybooc OTF" pitchFamily="34" charset="-122"/>
-                <a:cs typeface="paybooc OTF" pitchFamily="34" charset="-120"/>
+                <a:latin typeface="Pretendard Light" pitchFamily="34" charset="0"/>
+                <a:ea typeface="Pretendard Light" pitchFamily="34" charset="-122"/>
+                <a:cs typeface="Pretendard Light" pitchFamily="34" charset="-120"/>
               </a:rPr>
               <a:t>핵심</a:t>
             </a:r>
@@ -26155,9 +26155,9 @@
                 <a:solidFill>
                   <a:srgbClr val="0C0A09"/>
                 </a:solidFill>
-                <a:latin typeface="paybooc OTF" pitchFamily="34" charset="0"/>
-                <a:ea typeface="paybooc OTF" pitchFamily="34" charset="-122"/>
-                <a:cs typeface="paybooc OTF" pitchFamily="34" charset="-120"/>
+                <a:latin typeface="Pretendard Light" pitchFamily="34" charset="0"/>
+                <a:ea typeface="Pretendard Light" pitchFamily="34" charset="-122"/>
+                <a:cs typeface="Pretendard Light" pitchFamily="34" charset="-120"/>
               </a:rPr>
               <a:t>수수 사주교육</a:t>
             </a:r>
@@ -26193,9 +26193,9 @@
                 <a:solidFill>
                   <a:srgbClr val="777169"/>
                 </a:solidFill>
-                <a:latin typeface="paybooc OTF" pitchFamily="34" charset="0"/>
-                <a:ea typeface="paybooc OTF" pitchFamily="34" charset="-122"/>
-                <a:cs typeface="paybooc OTF" pitchFamily="34" charset="-120"/>
+                <a:latin typeface="Pretendard Light" pitchFamily="34" charset="0"/>
+                <a:ea typeface="Pretendard Light" pitchFamily="34" charset="-122"/>
+                <a:cs typeface="Pretendard Light" pitchFamily="34" charset="-120"/>
               </a:rPr>
               <a:t>01</a:t>
             </a:r>
@@ -26231,9 +26231,9 @@
                 <a:solidFill>
                   <a:srgbClr val="777169"/>
                 </a:solidFill>
-                <a:latin typeface="paybooc OTF" pitchFamily="34" charset="0"/>
-                <a:ea typeface="paybooc OTF" pitchFamily="34" charset="-122"/>
-                <a:cs typeface="paybooc OTF" pitchFamily="34" charset="-120"/>
+                <a:latin typeface="Pretendard Light" pitchFamily="34" charset="0"/>
+                <a:ea typeface="Pretendard Light" pitchFamily="34" charset="-122"/>
+                <a:cs typeface="Pretendard Light" pitchFamily="34" charset="-120"/>
               </a:rPr>
               <a:t>01 · 사주와 운의 관계</a:t>
             </a:r>
@@ -26307,9 +26307,9 @@
                 <a:solidFill>
                   <a:srgbClr val="777169"/>
                 </a:solidFill>
-                <a:latin typeface="paybooc OTF" pitchFamily="34" charset="0"/>
-                <a:ea typeface="paybooc OTF" pitchFamily="34" charset="-122"/>
-                <a:cs typeface="paybooc OTF" pitchFamily="34" charset="-120"/>
+                <a:latin typeface="Pretendard Light" pitchFamily="34" charset="0"/>
+                <a:ea typeface="Pretendard Light" pitchFamily="34" charset="-122"/>
+                <a:cs typeface="Pretendard Light" pitchFamily="34" charset="-120"/>
               </a:rPr>
               <a:t>좋은 차도 빙판길에선 미끄러진다</a:t>
             </a:r>
@@ -26439,9 +26439,9 @@
                 <a:solidFill>
                   <a:srgbClr val="0C0A09"/>
                 </a:solidFill>
-                <a:latin typeface="paybooc OTF" pitchFamily="34" charset="0"/>
-                <a:ea typeface="paybooc OTF" pitchFamily="34" charset="-122"/>
-                <a:cs typeface="paybooc OTF" pitchFamily="34" charset="-120"/>
+                <a:latin typeface="Pretendard Light" pitchFamily="34" charset="0"/>
+                <a:ea typeface="Pretendard Light" pitchFamily="34" charset="-122"/>
+                <a:cs typeface="Pretendard Light" pitchFamily="34" charset="-120"/>
               </a:rPr>
               <a:t>좋은 차 + 빙판길</a:t>
             </a:r>
@@ -26653,9 +26653,9 @@
                 <a:solidFill>
                   <a:srgbClr val="0C0A09"/>
                 </a:solidFill>
-                <a:latin typeface="paybooc OTF" pitchFamily="34" charset="0"/>
-                <a:ea typeface="paybooc OTF" pitchFamily="34" charset="-122"/>
-                <a:cs typeface="paybooc OTF" pitchFamily="34" charset="-120"/>
+                <a:latin typeface="Pretendard Light" pitchFamily="34" charset="0"/>
+                <a:ea typeface="Pretendard Light" pitchFamily="34" charset="-122"/>
+                <a:cs typeface="Pretendard Light" pitchFamily="34" charset="-120"/>
               </a:rPr>
               <a:t>낡은 차 + 고속도로</a:t>
             </a:r>
@@ -26807,9 +26807,9 @@
                 <a:solidFill>
                   <a:srgbClr val="777169"/>
                 </a:solidFill>
-                <a:latin typeface="paybooc OTF" pitchFamily="34" charset="0"/>
-                <a:ea typeface="paybooc OTF" pitchFamily="34" charset="-122"/>
-                <a:cs typeface="paybooc OTF" pitchFamily="34" charset="-120"/>
+                <a:latin typeface="Pretendard Light" pitchFamily="34" charset="0"/>
+                <a:ea typeface="Pretendard Light" pitchFamily="34" charset="-122"/>
+                <a:cs typeface="Pretendard Light" pitchFamily="34" charset="-120"/>
               </a:rPr>
               <a:t>그래서</a:t>
             </a:r>
@@ -27059,9 +27059,9 @@
                 <a:solidFill>
                   <a:srgbClr val="0C0A09"/>
                 </a:solidFill>
-                <a:latin typeface="paybooc OTF" pitchFamily="34" charset="0"/>
-                <a:ea typeface="paybooc OTF" pitchFamily="34" charset="-122"/>
-                <a:cs typeface="paybooc OTF" pitchFamily="34" charset="-120"/>
+                <a:latin typeface="Pretendard Light" pitchFamily="34" charset="0"/>
+                <a:ea typeface="Pretendard Light" pitchFamily="34" charset="-122"/>
+                <a:cs typeface="Pretendard Light" pitchFamily="34" charset="-120"/>
               </a:rPr>
               <a:t>수수 사주교육</a:t>
             </a:r>
@@ -27097,9 +27097,9 @@
                 <a:solidFill>
                   <a:srgbClr val="777169"/>
                 </a:solidFill>
-                <a:latin typeface="paybooc OTF" pitchFamily="34" charset="0"/>
-                <a:ea typeface="paybooc OTF" pitchFamily="34" charset="-122"/>
-                <a:cs typeface="paybooc OTF" pitchFamily="34" charset="-120"/>
+                <a:latin typeface="Pretendard Light" pitchFamily="34" charset="0"/>
+                <a:ea typeface="Pretendard Light" pitchFamily="34" charset="-122"/>
+                <a:cs typeface="Pretendard Light" pitchFamily="34" charset="-120"/>
               </a:rPr>
               <a:t>01</a:t>
             </a:r>
@@ -27135,9 +27135,9 @@
                 <a:solidFill>
                   <a:srgbClr val="777169"/>
                 </a:solidFill>
-                <a:latin typeface="paybooc OTF" pitchFamily="34" charset="0"/>
-                <a:ea typeface="paybooc OTF" pitchFamily="34" charset="-122"/>
-                <a:cs typeface="paybooc OTF" pitchFamily="34" charset="-120"/>
+                <a:latin typeface="Pretendard Light" pitchFamily="34" charset="0"/>
+                <a:ea typeface="Pretendard Light" pitchFamily="34" charset="-122"/>
+                <a:cs typeface="Pretendard Light" pitchFamily="34" charset="-120"/>
               </a:rPr>
               <a:t>01 · 사주와 운의 관계</a:t>
             </a:r>
@@ -27211,9 +27211,9 @@
                 <a:solidFill>
                   <a:srgbClr val="777169"/>
                 </a:solidFill>
-                <a:latin typeface="paybooc OTF" pitchFamily="34" charset="0"/>
-                <a:ea typeface="paybooc OTF" pitchFamily="34" charset="-122"/>
-                <a:cs typeface="paybooc OTF" pitchFamily="34" charset="-120"/>
+                <a:latin typeface="Pretendard Light" pitchFamily="34" charset="0"/>
+                <a:ea typeface="Pretendard Light" pitchFamily="34" charset="-122"/>
+                <a:cs typeface="Pretendard Light" pitchFamily="34" charset="-120"/>
               </a:rPr>
               <a:t>원국 위에 대운, 그 위에 세운</a:t>
             </a:r>
@@ -27283,9 +27283,9 @@
                 <a:solidFill>
                   <a:srgbClr val="777169"/>
                 </a:solidFill>
-                <a:latin typeface="paybooc OTF" pitchFamily="34" charset="0"/>
-                <a:ea typeface="paybooc OTF" pitchFamily="34" charset="-122"/>
-                <a:cs typeface="paybooc OTF" pitchFamily="34" charset="-120"/>
+                <a:latin typeface="Pretendard Light" pitchFamily="34" charset="0"/>
+                <a:ea typeface="Pretendard Light" pitchFamily="34" charset="-122"/>
+                <a:cs typeface="Pretendard Light" pitchFamily="34" charset="-120"/>
               </a:rPr>
               <a:t>평생 고정</a:t>
             </a:r>
@@ -27400,9 +27400,9 @@
                 <a:solidFill>
                   <a:srgbClr val="A8A29E"/>
                 </a:solidFill>
-                <a:latin typeface="paybooc OTF" pitchFamily="34" charset="0"/>
-                <a:ea typeface="paybooc OTF" pitchFamily="34" charset="-122"/>
-                <a:cs typeface="paybooc OTF" pitchFamily="34" charset="-120"/>
+                <a:latin typeface="Pretendard Light" pitchFamily="34" charset="0"/>
+                <a:ea typeface="Pretendard Light" pitchFamily="34" charset="-122"/>
+                <a:cs typeface="Pretendard Light" pitchFamily="34" charset="-120"/>
               </a:rPr>
               <a:t>→</a:t>
             </a:r>
@@ -27472,9 +27472,9 @@
                 <a:solidFill>
                   <a:srgbClr val="777169"/>
                 </a:solidFill>
-                <a:latin typeface="paybooc OTF" pitchFamily="34" charset="0"/>
-                <a:ea typeface="paybooc OTF" pitchFamily="34" charset="-122"/>
-                <a:cs typeface="paybooc OTF" pitchFamily="34" charset="-120"/>
+                <a:latin typeface="Pretendard Light" pitchFamily="34" charset="0"/>
+                <a:ea typeface="Pretendard Light" pitchFamily="34" charset="-122"/>
+                <a:cs typeface="Pretendard Light" pitchFamily="34" charset="-120"/>
               </a:rPr>
               <a:t>10년 단위</a:t>
             </a:r>
@@ -27589,9 +27589,9 @@
                 <a:solidFill>
                   <a:srgbClr val="A8A29E"/>
                 </a:solidFill>
-                <a:latin typeface="paybooc OTF" pitchFamily="34" charset="0"/>
-                <a:ea typeface="paybooc OTF" pitchFamily="34" charset="-122"/>
-                <a:cs typeface="paybooc OTF" pitchFamily="34" charset="-120"/>
+                <a:latin typeface="Pretendard Light" pitchFamily="34" charset="0"/>
+                <a:ea typeface="Pretendard Light" pitchFamily="34" charset="-122"/>
+                <a:cs typeface="Pretendard Light" pitchFamily="34" charset="-120"/>
               </a:rPr>
               <a:t>→</a:t>
             </a:r>
@@ -27661,9 +27661,9 @@
                 <a:solidFill>
                   <a:srgbClr val="777169"/>
                 </a:solidFill>
-                <a:latin typeface="paybooc OTF" pitchFamily="34" charset="0"/>
-                <a:ea typeface="paybooc OTF" pitchFamily="34" charset="-122"/>
-                <a:cs typeface="paybooc OTF" pitchFamily="34" charset="-120"/>
+                <a:latin typeface="Pretendard Light" pitchFamily="34" charset="0"/>
+                <a:ea typeface="Pretendard Light" pitchFamily="34" charset="-122"/>
+                <a:cs typeface="Pretendard Light" pitchFamily="34" charset="-120"/>
               </a:rPr>
               <a:t>1년 단위</a:t>
             </a:r>
@@ -27812,9 +27812,9 @@
                 <a:solidFill>
                   <a:srgbClr val="777169"/>
                 </a:solidFill>
-                <a:latin typeface="paybooc OTF" pitchFamily="34" charset="0"/>
-                <a:ea typeface="paybooc OTF" pitchFamily="34" charset="-122"/>
-                <a:cs typeface="paybooc OTF" pitchFamily="34" charset="-120"/>
+                <a:latin typeface="Pretendard Light" pitchFamily="34" charset="0"/>
+                <a:ea typeface="Pretendard Light" pitchFamily="34" charset="-122"/>
+                <a:cs typeface="Pretendard Light" pitchFamily="34" charset="-120"/>
               </a:rPr>
               <a:t>비유</a:t>
             </a:r>

</xml_diff>